<commit_message>
Update module FAQ and project pages, adjust last modified dates in sitemap, and refine birthday and finance homework instructions for clarity.
</commit_message>
<xml_diff>
--- a/docs/lectures/slides_10.pptx
+++ b/docs/lectures/slides_10.pptx
@@ -5,7 +5,7 @@
     <p:sldMasterId id="2147483659" r:id="rId1"/>
   </p:sldMasterIdLst>
   <p:notesMasterIdLst>
-    <p:notesMasterId r:id="rId38"/>
+    <p:notesMasterId r:id="rId39"/>
   </p:notesMasterIdLst>
   <p:sldIdLst>
     <p:sldId id="256" r:id="rId2"/>
@@ -26,24 +26,25 @@
     <p:sldId id="271" r:id="rId17"/>
     <p:sldId id="272" r:id="rId18"/>
     <p:sldId id="273" r:id="rId19"/>
-    <p:sldId id="274" r:id="rId20"/>
-    <p:sldId id="275" r:id="rId21"/>
-    <p:sldId id="276" r:id="rId22"/>
-    <p:sldId id="277" r:id="rId23"/>
-    <p:sldId id="278" r:id="rId24"/>
-    <p:sldId id="279" r:id="rId25"/>
-    <p:sldId id="280" r:id="rId26"/>
-    <p:sldId id="281" r:id="rId27"/>
-    <p:sldId id="282" r:id="rId28"/>
-    <p:sldId id="283" r:id="rId29"/>
-    <p:sldId id="284" r:id="rId30"/>
-    <p:sldId id="285" r:id="rId31"/>
-    <p:sldId id="286" r:id="rId32"/>
-    <p:sldId id="287" r:id="rId33"/>
-    <p:sldId id="288" r:id="rId34"/>
-    <p:sldId id="289" r:id="rId35"/>
-    <p:sldId id="290" r:id="rId36"/>
-    <p:sldId id="291" r:id="rId37"/>
+    <p:sldId id="292" r:id="rId20"/>
+    <p:sldId id="274" r:id="rId21"/>
+    <p:sldId id="275" r:id="rId22"/>
+    <p:sldId id="276" r:id="rId23"/>
+    <p:sldId id="277" r:id="rId24"/>
+    <p:sldId id="278" r:id="rId25"/>
+    <p:sldId id="279" r:id="rId26"/>
+    <p:sldId id="280" r:id="rId27"/>
+    <p:sldId id="281" r:id="rId28"/>
+    <p:sldId id="282" r:id="rId29"/>
+    <p:sldId id="283" r:id="rId30"/>
+    <p:sldId id="284" r:id="rId31"/>
+    <p:sldId id="285" r:id="rId32"/>
+    <p:sldId id="286" r:id="rId33"/>
+    <p:sldId id="287" r:id="rId34"/>
+    <p:sldId id="288" r:id="rId35"/>
+    <p:sldId id="289" r:id="rId36"/>
+    <p:sldId id="290" r:id="rId37"/>
+    <p:sldId id="291" r:id="rId38"/>
   </p:sldIdLst>
   <p:sldSz cx="9144000" cy="5143500" type="screen16x9"/>
   <p:notesSz cx="6858000" cy="9144000"/>
@@ -828,7 +829,47 @@
               </a:spcAft>
               <a:buNone/>
             </a:pPr>
-            <a:endParaRPr>
+            <a:r>
+              <a:rPr lang="en-GB" dirty="0">
+                <a:solidFill>
+                  <a:schemeClr val="dk1"/>
+                </a:solidFill>
+              </a:rPr>
+              <a:t>Point of this week – combine a web server with </a:t>
+            </a:r>
+            <a:r>
+              <a:rPr lang="en-GB" dirty="0" err="1">
+                <a:solidFill>
+                  <a:schemeClr val="dk1"/>
+                </a:solidFill>
+              </a:rPr>
+              <a:t>css</a:t>
+            </a:r>
+            <a:r>
+              <a:rPr lang="en-GB" dirty="0">
+                <a:solidFill>
+                  <a:schemeClr val="dk1"/>
+                </a:solidFill>
+              </a:rPr>
+              <a:t>, html maybe even </a:t>
+            </a:r>
+            <a:r>
+              <a:rPr lang="en-GB" dirty="0" err="1">
+                <a:solidFill>
+                  <a:schemeClr val="dk1"/>
+                </a:solidFill>
+              </a:rPr>
+              <a:t>javascript</a:t>
+            </a:r>
+            <a:r>
+              <a:rPr lang="en-GB" dirty="0">
+                <a:solidFill>
+                  <a:schemeClr val="dk1"/>
+                </a:solidFill>
+              </a:rPr>
+              <a:t>.</a:t>
+            </a:r>
+            <a:endParaRPr dirty="0">
               <a:solidFill>
                 <a:schemeClr val="dk1"/>
               </a:solidFill>
@@ -990,7 +1031,7 @@
         </p:nvSpPr>
         <p:spPr>
           <a:xfrm>
-            <a:off x="381300" y="685800"/>
+            <a:off x="381000" y="685800"/>
             <a:ext cx="6096000" cy="3429000"/>
           </a:xfrm>
           <a:custGeom>
@@ -1053,7 +1094,38 @@
               </a:spcAft>
               <a:buNone/>
             </a:pPr>
-            <a:endParaRPr/>
+            <a:r>
+              <a:rPr lang="en-GB" dirty="0"/>
+              <a:t>This is what happens on the server</a:t>
+            </a:r>
+          </a:p>
+          <a:p>
+            <a:pPr marL="0" lvl="0" indent="0" algn="l" rtl="0">
+              <a:spcBef>
+                <a:spcPts val="0"/>
+              </a:spcBef>
+              <a:spcAft>
+                <a:spcPts val="0"/>
+              </a:spcAft>
+              <a:buNone/>
+            </a:pPr>
+            <a:endParaRPr lang="en-GB" dirty="0"/>
+          </a:p>
+          <a:p>
+            <a:pPr marL="0" lvl="0" indent="0" algn="l" rtl="0">
+              <a:spcBef>
+                <a:spcPts val="0"/>
+              </a:spcBef>
+              <a:spcAft>
+                <a:spcPts val="0"/>
+              </a:spcAft>
+              <a:buNone/>
+            </a:pPr>
+            <a:r>
+              <a:rPr lang="en-GB" dirty="0"/>
+              <a:t>Could write code to do this...</a:t>
+            </a:r>
+            <a:endParaRPr dirty="0"/>
           </a:p>
         </p:txBody>
       </p:sp>
@@ -1094,7 +1166,7 @@
         </p:nvSpPr>
         <p:spPr>
           <a:xfrm>
-            <a:off x="381300" y="685800"/>
+            <a:off x="381000" y="685800"/>
             <a:ext cx="6096000" cy="3429000"/>
           </a:xfrm>
           <a:custGeom>
@@ -1157,7 +1229,11 @@
               </a:spcAft>
               <a:buNone/>
             </a:pPr>
-            <a:endParaRPr/>
+            <a:r>
+              <a:rPr lang="en-GB" dirty="0"/>
+              <a:t>Framework (library) that handles routes and key/values</a:t>
+            </a:r>
+            <a:endParaRPr dirty="0"/>
           </a:p>
         </p:txBody>
       </p:sp>
@@ -1198,7 +1274,7 @@
         </p:nvSpPr>
         <p:spPr>
           <a:xfrm>
-            <a:off x="381300" y="685800"/>
+            <a:off x="381000" y="685800"/>
             <a:ext cx="6096000" cy="3429000"/>
           </a:xfrm>
           <a:custGeom>
@@ -1261,7 +1337,11 @@
               </a:spcAft>
               <a:buNone/>
             </a:pPr>
-            <a:endParaRPr/>
+            <a:r>
+              <a:rPr lang="en-GB" dirty="0"/>
+              <a:t>Launch flask</a:t>
+            </a:r>
+            <a:endParaRPr dirty="0"/>
           </a:p>
         </p:txBody>
       </p:sp>
@@ -1302,7 +1382,7 @@
         </p:nvSpPr>
         <p:spPr>
           <a:xfrm>
-            <a:off x="381300" y="685800"/>
+            <a:off x="381000" y="685800"/>
             <a:ext cx="6096000" cy="3429000"/>
           </a:xfrm>
           <a:custGeom>
@@ -1365,7 +1445,11 @@
               </a:spcAft>
               <a:buNone/>
             </a:pPr>
-            <a:endParaRPr/>
+            <a:r>
+              <a:rPr lang="en-GB" dirty="0"/>
+              <a:t>Convention for files in flask - defaults</a:t>
+            </a:r>
+            <a:endParaRPr dirty="0"/>
           </a:p>
         </p:txBody>
       </p:sp>
@@ -1406,7 +1490,7 @@
         </p:nvSpPr>
         <p:spPr>
           <a:xfrm>
-            <a:off x="381300" y="685800"/>
+            <a:off x="381000" y="685800"/>
             <a:ext cx="6096000" cy="3429000"/>
           </a:xfrm>
           <a:custGeom>
@@ -1470,10 +1554,95 @@
               <a:buNone/>
             </a:pPr>
             <a:r>
-              <a:rPr lang="en"/>
+              <a:rPr lang="en-GB" dirty="0"/>
+              <a:t>S</a:t>
+            </a:r>
+            <a:r>
+              <a:rPr lang="en" dirty="0"/>
+              <a:t>implest of web apps</a:t>
+            </a:r>
+          </a:p>
+          <a:p>
+            <a:pPr marL="0" lvl="0" indent="0" algn="l" rtl="0">
+              <a:spcBef>
+                <a:spcPts val="0"/>
+              </a:spcBef>
+              <a:spcAft>
+                <a:spcPts val="0"/>
+              </a:spcAft>
+              <a:buNone/>
+            </a:pPr>
+            <a:endParaRPr lang="en" dirty="0"/>
+          </a:p>
+          <a:p>
+            <a:pPr marL="0" lvl="0" indent="0" algn="l" rtl="0">
+              <a:spcBef>
+                <a:spcPts val="0"/>
+              </a:spcBef>
+              <a:spcAft>
+                <a:spcPts val="0"/>
+              </a:spcAft>
+              <a:buNone/>
+            </a:pPr>
+            <a:r>
+              <a:rPr lang="en" dirty="0"/>
+              <a:t>“@” is a Python “decorator”</a:t>
+            </a:r>
+          </a:p>
+          <a:p>
+            <a:pPr marL="0" lvl="0" indent="0" algn="l" rtl="0">
+              <a:spcBef>
+                <a:spcPts val="0"/>
+              </a:spcBef>
+              <a:spcAft>
+                <a:spcPts val="0"/>
+              </a:spcAft>
+              <a:buNone/>
+            </a:pPr>
+            <a:endParaRPr lang="en" dirty="0"/>
+          </a:p>
+          <a:p>
+            <a:pPr marL="0" lvl="0" indent="0" algn="l" rtl="0">
+              <a:spcBef>
+                <a:spcPts val="0"/>
+              </a:spcBef>
+              <a:spcAft>
+                <a:spcPts val="0"/>
+              </a:spcAft>
+              <a:buNone/>
+            </a:pPr>
+            <a:r>
+              <a:rPr lang="en" dirty="0"/>
+              <a:t>Defines index for web app</a:t>
+            </a:r>
+          </a:p>
+          <a:p>
+            <a:pPr marL="0" lvl="0" indent="0" algn="l" rtl="0">
+              <a:spcBef>
+                <a:spcPts val="0"/>
+              </a:spcBef>
+              <a:spcAft>
+                <a:spcPts val="0"/>
+              </a:spcAft>
+              <a:buNone/>
+            </a:pPr>
+            <a:endParaRPr lang="en" dirty="0"/>
+          </a:p>
+          <a:p>
+            <a:pPr marL="0" lvl="0" indent="0" algn="l" rtl="0">
+              <a:spcBef>
+                <a:spcPts val="0"/>
+              </a:spcBef>
+              <a:spcAft>
+                <a:spcPts val="0"/>
+              </a:spcAft>
+              <a:buNone/>
+            </a:pPr>
+            <a:r>
+              <a:rPr lang="en" dirty="0"/>
               <a:t>hello0/</a:t>
             </a:r>
-            <a:endParaRPr/>
+            <a:endParaRPr dirty="0"/>
           </a:p>
         </p:txBody>
       </p:sp>
@@ -1626,7 +1795,7 @@
         </p:nvSpPr>
         <p:spPr>
           <a:xfrm>
-            <a:off x="381300" y="685800"/>
+            <a:off x="381000" y="685800"/>
             <a:ext cx="6096000" cy="3429000"/>
           </a:xfrm>
           <a:custGeom>
@@ -1690,10 +1859,64 @@
               <a:buNone/>
             </a:pPr>
             <a:r>
-              <a:rPr lang="en"/>
+              <a:rPr lang="en" dirty="0"/>
               <a:t>hello2/</a:t>
             </a:r>
-            <a:endParaRPr/>
+          </a:p>
+          <a:p>
+            <a:pPr marL="0" lvl="0" indent="0" algn="l" rtl="0">
+              <a:spcBef>
+                <a:spcPts val="0"/>
+              </a:spcBef>
+              <a:spcAft>
+                <a:spcPts val="0"/>
+              </a:spcAft>
+              <a:buNone/>
+            </a:pPr>
+            <a:endParaRPr lang="en" dirty="0"/>
+          </a:p>
+          <a:p>
+            <a:pPr marL="0" lvl="0" indent="0" algn="l" rtl="0">
+              <a:spcBef>
+                <a:spcPts val="0"/>
+              </a:spcBef>
+              <a:spcAft>
+                <a:spcPts val="0"/>
+              </a:spcAft>
+              <a:buNone/>
+            </a:pPr>
+            <a:r>
+              <a:rPr lang="en" dirty="0"/>
+              <a:t>This creates and returns an html template to the browser</a:t>
+            </a:r>
+          </a:p>
+          <a:p>
+            <a:pPr marL="0" lvl="0" indent="0" algn="l" rtl="0">
+              <a:spcBef>
+                <a:spcPts val="0"/>
+              </a:spcBef>
+              <a:spcAft>
+                <a:spcPts val="0"/>
+              </a:spcAft>
+              <a:buNone/>
+            </a:pPr>
+            <a:endParaRPr lang="en" dirty="0"/>
+          </a:p>
+          <a:p>
+            <a:pPr marL="0" lvl="0" indent="0" algn="l" rtl="0">
+              <a:spcBef>
+                <a:spcPts val="0"/>
+              </a:spcBef>
+              <a:spcAft>
+                <a:spcPts val="0"/>
+              </a:spcAft>
+              <a:buNone/>
+            </a:pPr>
+            <a:r>
+              <a:rPr lang="en" dirty="0"/>
+              <a:t>NB this associates the route (“/”) with an actual file on the server</a:t>
+            </a:r>
+            <a:endParaRPr dirty="0"/>
           </a:p>
         </p:txBody>
       </p:sp>
@@ -1734,7 +1957,7 @@
         </p:nvSpPr>
         <p:spPr>
           <a:xfrm>
-            <a:off x="381300" y="685800"/>
+            <a:off x="381000" y="685800"/>
             <a:ext cx="6096000" cy="3429000"/>
           </a:xfrm>
           <a:custGeom>
@@ -1797,7 +2020,76 @@
               </a:spcAft>
               <a:buNone/>
             </a:pPr>
-            <a:endParaRPr/>
+            <a:r>
+              <a:rPr lang="en-GB" dirty="0"/>
+              <a:t>Request variable in Flask </a:t>
+            </a:r>
+          </a:p>
+          <a:p>
+            <a:pPr marL="0" lvl="0" indent="0" algn="l" rtl="0">
+              <a:spcBef>
+                <a:spcPts val="0"/>
+              </a:spcBef>
+              <a:spcAft>
+                <a:spcPts val="0"/>
+              </a:spcAft>
+              <a:buNone/>
+            </a:pPr>
+            <a:endParaRPr lang="en-GB" dirty="0"/>
+          </a:p>
+          <a:p>
+            <a:pPr marL="0" lvl="0" indent="0" algn="l" rtl="0">
+              <a:spcBef>
+                <a:spcPts val="0"/>
+              </a:spcBef>
+              <a:spcAft>
+                <a:spcPts val="0"/>
+              </a:spcAft>
+              <a:buNone/>
+            </a:pPr>
+            <a:r>
+              <a:rPr lang="en-GB" dirty="0"/>
+              <a:t>Stores key value pairs</a:t>
+            </a:r>
+          </a:p>
+          <a:p>
+            <a:pPr marL="0" lvl="0" indent="0" algn="l" rtl="0">
+              <a:spcBef>
+                <a:spcPts val="0"/>
+              </a:spcBef>
+              <a:spcAft>
+                <a:spcPts val="0"/>
+              </a:spcAft>
+              <a:buNone/>
+            </a:pPr>
+            <a:endParaRPr lang="en-GB" dirty="0"/>
+          </a:p>
+          <a:p>
+            <a:pPr marL="0" lvl="0" indent="0" algn="l" rtl="0">
+              <a:spcBef>
+                <a:spcPts val="0"/>
+              </a:spcBef>
+              <a:spcAft>
+                <a:spcPts val="0"/>
+              </a:spcAft>
+              <a:buNone/>
+            </a:pPr>
+            <a:r>
+              <a:rPr lang="en-GB" dirty="0"/>
+              <a:t>Just an example because URL is hard coded and not dynamic</a:t>
+            </a:r>
+          </a:p>
+          <a:p>
+            <a:pPr marL="0" lvl="0" indent="0" algn="l" rtl="0">
+              <a:spcBef>
+                <a:spcPts val="0"/>
+              </a:spcBef>
+              <a:spcAft>
+                <a:spcPts val="0"/>
+              </a:spcAft>
+              <a:buNone/>
+            </a:pPr>
+            <a:endParaRPr dirty="0"/>
           </a:p>
         </p:txBody>
       </p:sp>
@@ -1810,6 +2102,395 @@
 </file>
 
 <file path=ppt/notesSlides/notesSlide19.xml><?xml version="1.0" encoding="utf-8"?>
+<p:notes xmlns:a="http://schemas.openxmlformats.org/drawingml/2006/main" xmlns:r="http://schemas.openxmlformats.org/officeDocument/2006/relationships" xmlns:p="http://schemas.openxmlformats.org/presentationml/2006/main" showMasterSp="0" showMasterPhAnim="0">
+  <p:cSld>
+    <p:spTree>
+      <p:nvGrpSpPr>
+        <p:cNvPr id="1" name="Shape 135">
+          <a:extLst>
+            <a:ext uri="{FF2B5EF4-FFF2-40B4-BE49-F238E27FC236}">
+              <a16:creationId xmlns:a16="http://schemas.microsoft.com/office/drawing/2014/main" id="{612992D7-8DE0-905D-95B1-7A93C5213D8C}"/>
+            </a:ext>
+          </a:extLst>
+        </p:cNvPr>
+        <p:cNvGrpSpPr/>
+        <p:nvPr/>
+      </p:nvGrpSpPr>
+      <p:grpSpPr>
+        <a:xfrm>
+          <a:off x="0" y="0"/>
+          <a:ext cx="0" cy="0"/>
+          <a:chOff x="0" y="0"/>
+          <a:chExt cx="0" cy="0"/>
+        </a:xfrm>
+      </p:grpSpPr>
+      <p:sp>
+        <p:nvSpPr>
+          <p:cNvPr id="136" name="Google Shape;136;g18401b6c2f9_0_89:notes">
+            <a:extLst>
+              <a:ext uri="{FF2B5EF4-FFF2-40B4-BE49-F238E27FC236}">
+                <a16:creationId xmlns:a16="http://schemas.microsoft.com/office/drawing/2014/main" id="{64702092-BF80-7E60-48E4-D99567763E27}"/>
+              </a:ext>
+            </a:extLst>
+          </p:cNvPr>
+          <p:cNvSpPr>
+            <a:spLocks noGrp="1" noRot="1" noChangeAspect="1"/>
+          </p:cNvSpPr>
+          <p:nvPr>
+            <p:ph type="sldImg" idx="2"/>
+          </p:nvPr>
+        </p:nvSpPr>
+        <p:spPr>
+          <a:xfrm>
+            <a:off x="381000" y="685800"/>
+            <a:ext cx="6096000" cy="3429000"/>
+          </a:xfrm>
+          <a:custGeom>
+            <a:avLst/>
+            <a:gdLst/>
+            <a:ahLst/>
+            <a:cxnLst/>
+            <a:rect l="l" t="t" r="r" b="b"/>
+            <a:pathLst>
+              <a:path w="120000" h="120000" extrusionOk="0">
+                <a:moveTo>
+                  <a:pt x="0" y="0"/>
+                </a:moveTo>
+                <a:lnTo>
+                  <a:pt x="120000" y="0"/>
+                </a:lnTo>
+                <a:lnTo>
+                  <a:pt x="120000" y="120000"/>
+                </a:lnTo>
+                <a:lnTo>
+                  <a:pt x="0" y="120000"/>
+                </a:lnTo>
+                <a:close/>
+              </a:path>
+            </a:pathLst>
+          </a:custGeom>
+        </p:spPr>
+      </p:sp>
+      <p:sp>
+        <p:nvSpPr>
+          <p:cNvPr id="137" name="Google Shape;137;g18401b6c2f9_0_89:notes">
+            <a:extLst>
+              <a:ext uri="{FF2B5EF4-FFF2-40B4-BE49-F238E27FC236}">
+                <a16:creationId xmlns:a16="http://schemas.microsoft.com/office/drawing/2014/main" id="{22FA58D3-70E7-B31C-E0B0-0EC369098A89}"/>
+              </a:ext>
+            </a:extLst>
+          </p:cNvPr>
+          <p:cNvSpPr txBox="1">
+            <a:spLocks noGrp="1"/>
+          </p:cNvSpPr>
+          <p:nvPr>
+            <p:ph type="body" idx="1"/>
+          </p:nvPr>
+        </p:nvSpPr>
+        <p:spPr>
+          <a:xfrm>
+            <a:off x="685800" y="4343400"/>
+            <a:ext cx="5486400" cy="4114800"/>
+          </a:xfrm>
+          <a:prstGeom prst="rect">
+            <a:avLst/>
+          </a:prstGeom>
+        </p:spPr>
+        <p:txBody>
+          <a:bodyPr spcFirstLastPara="1" wrap="square" lIns="91425" tIns="91425" rIns="91425" bIns="91425" anchor="t" anchorCtr="0">
+            <a:noAutofit/>
+          </a:bodyPr>
+          <a:lstStyle/>
+          <a:p>
+            <a:pPr marL="0" lvl="0" indent="0" algn="l" rtl="0">
+              <a:spcBef>
+                <a:spcPts val="0"/>
+              </a:spcBef>
+              <a:spcAft>
+                <a:spcPts val="0"/>
+              </a:spcAft>
+              <a:buNone/>
+            </a:pPr>
+            <a:r>
+              <a:rPr lang="en-GB" dirty="0"/>
+              <a:t>Request variable in Flask </a:t>
+            </a:r>
+          </a:p>
+          <a:p>
+            <a:pPr marL="0" lvl="0" indent="0" algn="l" rtl="0">
+              <a:spcBef>
+                <a:spcPts val="0"/>
+              </a:spcBef>
+              <a:spcAft>
+                <a:spcPts val="0"/>
+              </a:spcAft>
+              <a:buNone/>
+            </a:pPr>
+            <a:endParaRPr lang="en-GB" dirty="0"/>
+          </a:p>
+          <a:p>
+            <a:pPr marL="0" lvl="0" indent="0" algn="l" rtl="0">
+              <a:spcBef>
+                <a:spcPts val="0"/>
+              </a:spcBef>
+              <a:spcAft>
+                <a:spcPts val="0"/>
+              </a:spcAft>
+              <a:buNone/>
+            </a:pPr>
+            <a:r>
+              <a:rPr lang="en-GB" dirty="0"/>
+              <a:t>Stores key value pairs</a:t>
+            </a:r>
+          </a:p>
+          <a:p>
+            <a:pPr marL="0" lvl="0" indent="0" algn="l" rtl="0">
+              <a:spcBef>
+                <a:spcPts val="0"/>
+              </a:spcBef>
+              <a:spcAft>
+                <a:spcPts val="0"/>
+              </a:spcAft>
+              <a:buNone/>
+            </a:pPr>
+            <a:endParaRPr lang="en-GB" dirty="0"/>
+          </a:p>
+          <a:p>
+            <a:pPr marL="0" lvl="0" indent="0" algn="l" rtl="0">
+              <a:spcBef>
+                <a:spcPts val="0"/>
+              </a:spcBef>
+              <a:spcAft>
+                <a:spcPts val="0"/>
+              </a:spcAft>
+              <a:buNone/>
+            </a:pPr>
+            <a:r>
+              <a:rPr lang="en-GB" dirty="0"/>
+              <a:t>Just an example because URL is hard coded and not dynamic</a:t>
+            </a:r>
+          </a:p>
+          <a:p>
+            <a:pPr marL="0" lvl="0" indent="0" algn="l" rtl="0">
+              <a:spcBef>
+                <a:spcPts val="0"/>
+              </a:spcBef>
+              <a:spcAft>
+                <a:spcPts val="0"/>
+              </a:spcAft>
+              <a:buNone/>
+            </a:pPr>
+            <a:endParaRPr dirty="0"/>
+          </a:p>
+        </p:txBody>
+      </p:sp>
+    </p:spTree>
+    <p:extLst>
+      <p:ext uri="{BB962C8B-B14F-4D97-AF65-F5344CB8AC3E}">
+        <p14:creationId xmlns:p14="http://schemas.microsoft.com/office/powerpoint/2010/main" val="1617832093"/>
+      </p:ext>
+    </p:extLst>
+  </p:cSld>
+  <p:clrMapOvr>
+    <a:masterClrMapping/>
+  </p:clrMapOvr>
+</p:notes>
+</file>
+
+<file path=ppt/notesSlides/notesSlide2.xml><?xml version="1.0" encoding="utf-8"?>
+<p:notes xmlns:a="http://schemas.openxmlformats.org/drawingml/2006/main" xmlns:r="http://schemas.openxmlformats.org/officeDocument/2006/relationships" xmlns:p="http://schemas.openxmlformats.org/presentationml/2006/main" showMasterSp="0" showMasterPhAnim="0">
+  <p:cSld>
+    <p:spTree>
+      <p:nvGrpSpPr>
+        <p:cNvPr id="1" name="Shape 55"/>
+        <p:cNvGrpSpPr/>
+        <p:nvPr/>
+      </p:nvGrpSpPr>
+      <p:grpSpPr>
+        <a:xfrm>
+          <a:off x="0" y="0"/>
+          <a:ext cx="0" cy="0"/>
+          <a:chOff x="0" y="0"/>
+          <a:chExt cx="0" cy="0"/>
+        </a:xfrm>
+      </p:grpSpPr>
+      <p:sp>
+        <p:nvSpPr>
+          <p:cNvPr id="56" name="Google Shape;56;g9f210aecbc_0_154:notes"/>
+          <p:cNvSpPr>
+            <a:spLocks noGrp="1" noRot="1" noChangeAspect="1"/>
+          </p:cNvSpPr>
+          <p:nvPr>
+            <p:ph type="sldImg" idx="2"/>
+          </p:nvPr>
+        </p:nvSpPr>
+        <p:spPr>
+          <a:xfrm>
+            <a:off x="381000" y="685800"/>
+            <a:ext cx="6096000" cy="3429000"/>
+          </a:xfrm>
+          <a:custGeom>
+            <a:avLst/>
+            <a:gdLst/>
+            <a:ahLst/>
+            <a:cxnLst/>
+            <a:rect l="l" t="t" r="r" b="b"/>
+            <a:pathLst>
+              <a:path w="120000" h="120000" extrusionOk="0">
+                <a:moveTo>
+                  <a:pt x="0" y="0"/>
+                </a:moveTo>
+                <a:lnTo>
+                  <a:pt x="120000" y="0"/>
+                </a:lnTo>
+                <a:lnTo>
+                  <a:pt x="120000" y="120000"/>
+                </a:lnTo>
+                <a:lnTo>
+                  <a:pt x="0" y="120000"/>
+                </a:lnTo>
+                <a:close/>
+              </a:path>
+            </a:pathLst>
+          </a:custGeom>
+        </p:spPr>
+      </p:sp>
+      <p:sp>
+        <p:nvSpPr>
+          <p:cNvPr id="57" name="Google Shape;57;g9f210aecbc_0_154:notes"/>
+          <p:cNvSpPr txBox="1">
+            <a:spLocks noGrp="1"/>
+          </p:cNvSpPr>
+          <p:nvPr>
+            <p:ph type="body" idx="1"/>
+          </p:nvPr>
+        </p:nvSpPr>
+        <p:spPr>
+          <a:xfrm>
+            <a:off x="685800" y="4343400"/>
+            <a:ext cx="5486400" cy="4114800"/>
+          </a:xfrm>
+          <a:prstGeom prst="rect">
+            <a:avLst/>
+          </a:prstGeom>
+        </p:spPr>
+        <p:txBody>
+          <a:bodyPr spcFirstLastPara="1" wrap="square" lIns="91425" tIns="91425" rIns="91425" bIns="91425" anchor="t" anchorCtr="0">
+            <a:noAutofit/>
+          </a:bodyPr>
+          <a:lstStyle/>
+          <a:p>
+            <a:pPr marL="0" lvl="0" indent="0" algn="l" rtl="0">
+              <a:spcBef>
+                <a:spcPts val="0"/>
+              </a:spcBef>
+              <a:spcAft>
+                <a:spcPts val="0"/>
+              </a:spcAft>
+              <a:buNone/>
+            </a:pPr>
+            <a:r>
+              <a:rPr lang="en-GB" dirty="0"/>
+              <a:t>Command to serve local web pages (used last week) – NB STATIC pages we load in browser</a:t>
+            </a:r>
+          </a:p>
+          <a:p>
+            <a:pPr marL="0" lvl="0" indent="0" algn="l" rtl="0">
+              <a:spcBef>
+                <a:spcPts val="0"/>
+              </a:spcBef>
+              <a:spcAft>
+                <a:spcPts val="0"/>
+              </a:spcAft>
+              <a:buNone/>
+            </a:pPr>
+            <a:endParaRPr lang="en-GB" dirty="0"/>
+          </a:p>
+          <a:p>
+            <a:pPr marL="0" lvl="0" indent="0" algn="l" rtl="0">
+              <a:spcBef>
+                <a:spcPts val="0"/>
+              </a:spcBef>
+              <a:spcAft>
+                <a:spcPts val="0"/>
+              </a:spcAft>
+              <a:buNone/>
+            </a:pPr>
+            <a:r>
+              <a:rPr lang="en-GB" dirty="0" err="1"/>
+              <a:t>Javascript</a:t>
+            </a:r>
+            <a:r>
+              <a:rPr lang="en-GB" dirty="0"/>
+              <a:t> allows dynamic actions (e.g. autocomplete)</a:t>
+            </a:r>
+          </a:p>
+          <a:p>
+            <a:pPr marL="0" lvl="0" indent="0" algn="l" rtl="0">
+              <a:spcBef>
+                <a:spcPts val="0"/>
+              </a:spcBef>
+              <a:spcAft>
+                <a:spcPts val="0"/>
+              </a:spcAft>
+              <a:buNone/>
+            </a:pPr>
+            <a:endParaRPr lang="en-GB" dirty="0"/>
+          </a:p>
+          <a:p>
+            <a:pPr marL="0" lvl="0" indent="0" algn="l" rtl="0">
+              <a:spcBef>
+                <a:spcPts val="0"/>
+              </a:spcBef>
+              <a:spcAft>
+                <a:spcPts val="0"/>
+              </a:spcAft>
+              <a:buNone/>
+            </a:pPr>
+            <a:r>
+              <a:rPr lang="en-GB" dirty="0"/>
+              <a:t>This all done locally</a:t>
+            </a:r>
+          </a:p>
+          <a:p>
+            <a:pPr marL="0" lvl="0" indent="0" algn="l" rtl="0">
+              <a:spcBef>
+                <a:spcPts val="0"/>
+              </a:spcBef>
+              <a:spcAft>
+                <a:spcPts val="0"/>
+              </a:spcAft>
+              <a:buNone/>
+            </a:pPr>
+            <a:endParaRPr lang="en-GB" dirty="0"/>
+          </a:p>
+          <a:p>
+            <a:pPr marL="0" lvl="0" indent="0" algn="l" rtl="0">
+              <a:spcBef>
+                <a:spcPts val="0"/>
+              </a:spcBef>
+              <a:spcAft>
+                <a:spcPts val="0"/>
+              </a:spcAft>
+              <a:buNone/>
+            </a:pPr>
+            <a:r>
+              <a:rPr lang="en-GB" dirty="0"/>
+              <a:t>Today we move things to server side!</a:t>
+            </a:r>
+            <a:endParaRPr dirty="0"/>
+          </a:p>
+        </p:txBody>
+      </p:sp>
+    </p:spTree>
+  </p:cSld>
+  <p:clrMapOvr>
+    <a:masterClrMapping/>
+  </p:clrMapOvr>
+</p:notes>
+</file>
+
+<file path=ppt/notesSlides/notesSlide20.xml><?xml version="1.0" encoding="utf-8"?>
 <p:notes xmlns:a="http://schemas.openxmlformats.org/drawingml/2006/main" xmlns:r="http://schemas.openxmlformats.org/officeDocument/2006/relationships" xmlns:p="http://schemas.openxmlformats.org/presentationml/2006/main" showMasterSp="0" showMasterPhAnim="0">
   <p:cSld>
     <p:spTree>
@@ -1838,7 +2519,7 @@
         </p:nvSpPr>
         <p:spPr>
           <a:xfrm>
-            <a:off x="381300" y="685800"/>
+            <a:off x="381000" y="685800"/>
             <a:ext cx="6096000" cy="3429000"/>
           </a:xfrm>
           <a:custGeom>
@@ -1907,14 +2588,14 @@
               <a:buNone/>
             </a:pPr>
             <a:r>
-              <a:rPr lang="en">
+              <a:rPr lang="en" dirty="0">
                 <a:solidFill>
                   <a:schemeClr val="dk1"/>
                 </a:solidFill>
               </a:rPr>
               <a:t>hello{3,4,5,6,7}/</a:t>
             </a:r>
-            <a:endParaRPr>
+            <a:endParaRPr dirty="0">
               <a:solidFill>
                 <a:schemeClr val="dk1"/>
               </a:solidFill>
@@ -1930,7 +2611,23 @@
               </a:spcAft>
               <a:buNone/>
             </a:pPr>
-            <a:endParaRPr/>
+            <a:endParaRPr lang="en-GB" dirty="0"/>
+          </a:p>
+          <a:p>
+            <a:pPr marL="0" lvl="0" indent="0" algn="l" rtl="0">
+              <a:spcBef>
+                <a:spcPts val="0"/>
+              </a:spcBef>
+              <a:spcAft>
+                <a:spcPts val="0"/>
+              </a:spcAft>
+              <a:buNone/>
+            </a:pPr>
+            <a:r>
+              <a:rPr lang="en-GB" dirty="0"/>
+              <a:t>Jinja == Templating library that Flask uses – e.g. looks for variables in {{ variable }} syntax</a:t>
+            </a:r>
+            <a:endParaRPr dirty="0"/>
           </a:p>
         </p:txBody>
       </p:sp>
@@ -1942,111 +2639,7 @@
 </p:notes>
 </file>
 
-<file path=ppt/notesSlides/notesSlide2.xml><?xml version="1.0" encoding="utf-8"?>
-<p:notes xmlns:a="http://schemas.openxmlformats.org/drawingml/2006/main" xmlns:r="http://schemas.openxmlformats.org/officeDocument/2006/relationships" xmlns:p="http://schemas.openxmlformats.org/presentationml/2006/main" showMasterSp="0" showMasterPhAnim="0">
-  <p:cSld>
-    <p:spTree>
-      <p:nvGrpSpPr>
-        <p:cNvPr id="1" name="Shape 55"/>
-        <p:cNvGrpSpPr/>
-        <p:nvPr/>
-      </p:nvGrpSpPr>
-      <p:grpSpPr>
-        <a:xfrm>
-          <a:off x="0" y="0"/>
-          <a:ext cx="0" cy="0"/>
-          <a:chOff x="0" y="0"/>
-          <a:chExt cx="0" cy="0"/>
-        </a:xfrm>
-      </p:grpSpPr>
-      <p:sp>
-        <p:nvSpPr>
-          <p:cNvPr id="56" name="Google Shape;56;g9f210aecbc_0_154:notes"/>
-          <p:cNvSpPr>
-            <a:spLocks noGrp="1" noRot="1" noChangeAspect="1"/>
-          </p:cNvSpPr>
-          <p:nvPr>
-            <p:ph type="sldImg" idx="2"/>
-          </p:nvPr>
-        </p:nvSpPr>
-        <p:spPr>
-          <a:xfrm>
-            <a:off x="381300" y="685800"/>
-            <a:ext cx="6096000" cy="3429000"/>
-          </a:xfrm>
-          <a:custGeom>
-            <a:avLst/>
-            <a:gdLst/>
-            <a:ahLst/>
-            <a:cxnLst/>
-            <a:rect l="l" t="t" r="r" b="b"/>
-            <a:pathLst>
-              <a:path w="120000" h="120000" extrusionOk="0">
-                <a:moveTo>
-                  <a:pt x="0" y="0"/>
-                </a:moveTo>
-                <a:lnTo>
-                  <a:pt x="120000" y="0"/>
-                </a:lnTo>
-                <a:lnTo>
-                  <a:pt x="120000" y="120000"/>
-                </a:lnTo>
-                <a:lnTo>
-                  <a:pt x="0" y="120000"/>
-                </a:lnTo>
-                <a:close/>
-              </a:path>
-            </a:pathLst>
-          </a:custGeom>
-        </p:spPr>
-      </p:sp>
-      <p:sp>
-        <p:nvSpPr>
-          <p:cNvPr id="57" name="Google Shape;57;g9f210aecbc_0_154:notes"/>
-          <p:cNvSpPr txBox="1">
-            <a:spLocks noGrp="1"/>
-          </p:cNvSpPr>
-          <p:nvPr>
-            <p:ph type="body" idx="1"/>
-          </p:nvPr>
-        </p:nvSpPr>
-        <p:spPr>
-          <a:xfrm>
-            <a:off x="685800" y="4343400"/>
-            <a:ext cx="5486400" cy="4114800"/>
-          </a:xfrm>
-          <a:prstGeom prst="rect">
-            <a:avLst/>
-          </a:prstGeom>
-        </p:spPr>
-        <p:txBody>
-          <a:bodyPr spcFirstLastPara="1" wrap="square" lIns="91425" tIns="91425" rIns="91425" bIns="91425" anchor="t" anchorCtr="0">
-            <a:noAutofit/>
-          </a:bodyPr>
-          <a:lstStyle/>
-          <a:p>
-            <a:pPr marL="0" lvl="0" indent="0" algn="l" rtl="0">
-              <a:spcBef>
-                <a:spcPts val="0"/>
-              </a:spcBef>
-              <a:spcAft>
-                <a:spcPts val="0"/>
-              </a:spcAft>
-              <a:buNone/>
-            </a:pPr>
-            <a:endParaRPr/>
-          </a:p>
-        </p:txBody>
-      </p:sp>
-    </p:spTree>
-  </p:cSld>
-  <p:clrMapOvr>
-    <a:masterClrMapping/>
-  </p:clrMapOvr>
-</p:notes>
-</file>
-
-<file path=ppt/notesSlides/notesSlide20.xml><?xml version="1.0" encoding="utf-8"?>
+<file path=ppt/notesSlides/notesSlide21.xml><?xml version="1.0" encoding="utf-8"?>
 <p:notes xmlns:a="http://schemas.openxmlformats.org/drawingml/2006/main" xmlns:r="http://schemas.openxmlformats.org/officeDocument/2006/relationships" xmlns:p="http://schemas.openxmlformats.org/presentationml/2006/main" showMasterSp="0" showMasterPhAnim="0">
   <p:cSld>
     <p:spTree>
@@ -2158,7 +2751,7 @@
 </p:notes>
 </file>
 
-<file path=ppt/notesSlides/notesSlide21.xml><?xml version="1.0" encoding="utf-8"?>
+<file path=ppt/notesSlides/notesSlide22.xml><?xml version="1.0" encoding="utf-8"?>
 <p:notes xmlns:a="http://schemas.openxmlformats.org/drawingml/2006/main" xmlns:r="http://schemas.openxmlformats.org/officeDocument/2006/relationships" xmlns:p="http://schemas.openxmlformats.org/presentationml/2006/main" showMasterSp="0" showMasterPhAnim="0">
   <p:cSld>
     <p:spTree>
@@ -2266,7 +2859,7 @@
 </p:notes>
 </file>
 
-<file path=ppt/notesSlides/notesSlide22.xml><?xml version="1.0" encoding="utf-8"?>
+<file path=ppt/notesSlides/notesSlide23.xml><?xml version="1.0" encoding="utf-8"?>
 <p:notes xmlns:a="http://schemas.openxmlformats.org/drawingml/2006/main" xmlns:r="http://schemas.openxmlformats.org/officeDocument/2006/relationships" xmlns:p="http://schemas.openxmlformats.org/presentationml/2006/main" showMasterSp="0" showMasterPhAnim="0">
   <p:cSld>
     <p:spTree>
@@ -2295,7 +2888,7 @@
         </p:nvSpPr>
         <p:spPr>
           <a:xfrm>
-            <a:off x="381300" y="685800"/>
+            <a:off x="381000" y="685800"/>
             <a:ext cx="6096000" cy="3429000"/>
           </a:xfrm>
           <a:custGeom>
@@ -2359,10 +2952,37 @@
               <a:buNone/>
             </a:pPr>
             <a:r>
-              <a:rPr lang="en"/>
+              <a:rPr lang="en" dirty="0"/>
               <a:t>froshims{0,1,2,3,4,5}/</a:t>
             </a:r>
-            <a:endParaRPr/>
+          </a:p>
+          <a:p>
+            <a:pPr marL="0" lvl="0" indent="0" algn="l" rtl="0">
+              <a:spcBef>
+                <a:spcPts val="0"/>
+              </a:spcBef>
+              <a:spcAft>
+                <a:spcPts val="0"/>
+              </a:spcAft>
+              <a:buNone/>
+            </a:pPr>
+            <a:endParaRPr lang="en" dirty="0"/>
+          </a:p>
+          <a:p>
+            <a:pPr marL="0" lvl="0" indent="0" algn="l" rtl="0">
+              <a:spcBef>
+                <a:spcPts val="0"/>
+              </a:spcBef>
+              <a:spcAft>
+                <a:spcPts val="0"/>
+              </a:spcAft>
+              <a:buNone/>
+            </a:pPr>
+            <a:r>
+              <a:rPr lang="en" dirty="0"/>
+              <a:t>Examine a web app that allows students to register for sports</a:t>
+            </a:r>
+            <a:endParaRPr dirty="0"/>
           </a:p>
         </p:txBody>
       </p:sp>
@@ -2374,7 +2994,7 @@
 </p:notes>
 </file>
 
-<file path=ppt/notesSlides/notesSlide23.xml><?xml version="1.0" encoding="utf-8"?>
+<file path=ppt/notesSlides/notesSlide24.xml><?xml version="1.0" encoding="utf-8"?>
 <p:notes xmlns:a="http://schemas.openxmlformats.org/drawingml/2006/main" xmlns:r="http://schemas.openxmlformats.org/officeDocument/2006/relationships" xmlns:p="http://schemas.openxmlformats.org/presentationml/2006/main" showMasterSp="0" showMasterPhAnim="0">
   <p:cSld>
     <p:spTree>
@@ -2478,7 +3098,7 @@
 </p:notes>
 </file>
 
-<file path=ppt/notesSlides/notesSlide24.xml><?xml version="1.0" encoding="utf-8"?>
+<file path=ppt/notesSlides/notesSlide25.xml><?xml version="1.0" encoding="utf-8"?>
 <p:notes xmlns:a="http://schemas.openxmlformats.org/drawingml/2006/main" xmlns:r="http://schemas.openxmlformats.org/officeDocument/2006/relationships" xmlns:p="http://schemas.openxmlformats.org/presentationml/2006/main" showMasterSp="0" showMasterPhAnim="0">
   <p:cSld>
     <p:spTree>
@@ -2582,7 +3202,7 @@
 </p:notes>
 </file>
 
-<file path=ppt/notesSlides/notesSlide25.xml><?xml version="1.0" encoding="utf-8"?>
+<file path=ppt/notesSlides/notesSlide26.xml><?xml version="1.0" encoding="utf-8"?>
 <p:notes xmlns:a="http://schemas.openxmlformats.org/drawingml/2006/main" xmlns:r="http://schemas.openxmlformats.org/officeDocument/2006/relationships" xmlns:p="http://schemas.openxmlformats.org/presentationml/2006/main" showMasterSp="0" showMasterPhAnim="0">
   <p:cSld>
     <p:spTree>
@@ -2611,7 +3231,7 @@
         </p:nvSpPr>
         <p:spPr>
           <a:xfrm>
-            <a:off x="381300" y="685800"/>
+            <a:off x="381000" y="685800"/>
             <a:ext cx="6096000" cy="3429000"/>
           </a:xfrm>
           <a:custGeom>
@@ -2674,7 +3294,11 @@
               </a:spcAft>
               <a:buNone/>
             </a:pPr>
-            <a:endParaRPr/>
+            <a:r>
+              <a:rPr lang="en-GB" dirty="0"/>
+              <a:t>Login / authentication</a:t>
+            </a:r>
+            <a:endParaRPr dirty="0"/>
           </a:p>
         </p:txBody>
       </p:sp>
@@ -2686,7 +3310,7 @@
 </p:notes>
 </file>
 
-<file path=ppt/notesSlides/notesSlide26.xml><?xml version="1.0" encoding="utf-8"?>
+<file path=ppt/notesSlides/notesSlide27.xml><?xml version="1.0" encoding="utf-8"?>
 <p:notes xmlns:a="http://schemas.openxmlformats.org/drawingml/2006/main" xmlns:r="http://schemas.openxmlformats.org/officeDocument/2006/relationships" xmlns:p="http://schemas.openxmlformats.org/presentationml/2006/main" showMasterSp="0" showMasterPhAnim="0">
   <p:cSld>
     <p:spTree>
@@ -2790,7 +3414,7 @@
 </p:notes>
 </file>
 
-<file path=ppt/notesSlides/notesSlide27.xml><?xml version="1.0" encoding="utf-8"?>
+<file path=ppt/notesSlides/notesSlide28.xml><?xml version="1.0" encoding="utf-8"?>
 <p:notes xmlns:a="http://schemas.openxmlformats.org/drawingml/2006/main" xmlns:r="http://schemas.openxmlformats.org/officeDocument/2006/relationships" xmlns:p="http://schemas.openxmlformats.org/presentationml/2006/main" showMasterSp="0" showMasterPhAnim="0">
   <p:cSld>
     <p:spTree>
@@ -2894,7 +3518,7 @@
 </p:notes>
 </file>
 
-<file path=ppt/notesSlides/notesSlide28.xml><?xml version="1.0" encoding="utf-8"?>
+<file path=ppt/notesSlides/notesSlide29.xml><?xml version="1.0" encoding="utf-8"?>
 <p:notes xmlns:a="http://schemas.openxmlformats.org/drawingml/2006/main" xmlns:r="http://schemas.openxmlformats.org/officeDocument/2006/relationships" xmlns:p="http://schemas.openxmlformats.org/presentationml/2006/main" showMasterSp="0" showMasterPhAnim="0">
   <p:cSld>
     <p:spTree>
@@ -2998,7 +3622,126 @@
 </p:notes>
 </file>
 
-<file path=ppt/notesSlides/notesSlide29.xml><?xml version="1.0" encoding="utf-8"?>
+<file path=ppt/notesSlides/notesSlide3.xml><?xml version="1.0" encoding="utf-8"?>
+<p:notes xmlns:a="http://schemas.openxmlformats.org/drawingml/2006/main" xmlns:r="http://schemas.openxmlformats.org/officeDocument/2006/relationships" xmlns:p="http://schemas.openxmlformats.org/presentationml/2006/main" showMasterSp="0" showMasterPhAnim="0">
+  <p:cSld>
+    <p:spTree>
+      <p:nvGrpSpPr>
+        <p:cNvPr id="1" name="Shape 60"/>
+        <p:cNvGrpSpPr/>
+        <p:nvPr/>
+      </p:nvGrpSpPr>
+      <p:grpSpPr>
+        <a:xfrm>
+          <a:off x="0" y="0"/>
+          <a:ext cx="0" cy="0"/>
+          <a:chOff x="0" y="0"/>
+          <a:chExt cx="0" cy="0"/>
+        </a:xfrm>
+      </p:grpSpPr>
+      <p:sp>
+        <p:nvSpPr>
+          <p:cNvPr id="61" name="Google Shape;61;g18401b6c2f9_0_4:notes"/>
+          <p:cNvSpPr>
+            <a:spLocks noGrp="1" noRot="1" noChangeAspect="1"/>
+          </p:cNvSpPr>
+          <p:nvPr>
+            <p:ph type="sldImg" idx="2"/>
+          </p:nvPr>
+        </p:nvSpPr>
+        <p:spPr>
+          <a:xfrm>
+            <a:off x="381000" y="685800"/>
+            <a:ext cx="6096000" cy="3429000"/>
+          </a:xfrm>
+          <a:custGeom>
+            <a:avLst/>
+            <a:gdLst/>
+            <a:ahLst/>
+            <a:cxnLst/>
+            <a:rect l="l" t="t" r="r" b="b"/>
+            <a:pathLst>
+              <a:path w="120000" h="120000" extrusionOk="0">
+                <a:moveTo>
+                  <a:pt x="0" y="0"/>
+                </a:moveTo>
+                <a:lnTo>
+                  <a:pt x="120000" y="0"/>
+                </a:lnTo>
+                <a:lnTo>
+                  <a:pt x="120000" y="120000"/>
+                </a:lnTo>
+                <a:lnTo>
+                  <a:pt x="0" y="120000"/>
+                </a:lnTo>
+                <a:close/>
+              </a:path>
+            </a:pathLst>
+          </a:custGeom>
+        </p:spPr>
+      </p:sp>
+      <p:sp>
+        <p:nvSpPr>
+          <p:cNvPr id="62" name="Google Shape;62;g18401b6c2f9_0_4:notes"/>
+          <p:cNvSpPr txBox="1">
+            <a:spLocks noGrp="1"/>
+          </p:cNvSpPr>
+          <p:nvPr>
+            <p:ph type="body" idx="1"/>
+          </p:nvPr>
+        </p:nvSpPr>
+        <p:spPr>
+          <a:xfrm>
+            <a:off x="685800" y="4343400"/>
+            <a:ext cx="5486400" cy="4114800"/>
+          </a:xfrm>
+          <a:prstGeom prst="rect">
+            <a:avLst/>
+          </a:prstGeom>
+        </p:spPr>
+        <p:txBody>
+          <a:bodyPr spcFirstLastPara="1" wrap="square" lIns="91425" tIns="91425" rIns="91425" bIns="91425" anchor="t" anchorCtr="0">
+            <a:noAutofit/>
+          </a:bodyPr>
+          <a:lstStyle/>
+          <a:p>
+            <a:pPr marL="0" lvl="0" indent="0" algn="l" rtl="0">
+              <a:spcBef>
+                <a:spcPts val="0"/>
+              </a:spcBef>
+              <a:spcAft>
+                <a:spcPts val="0"/>
+              </a:spcAft>
+              <a:buNone/>
+            </a:pPr>
+            <a:r>
+              <a:rPr lang="en-GB" dirty="0"/>
+              <a:t>Slash at end indicates we want to “default page” for the website (typically index.html)</a:t>
+            </a:r>
+          </a:p>
+          <a:p>
+            <a:pPr marL="0" lvl="0" indent="0" algn="l" rtl="0">
+              <a:spcBef>
+                <a:spcPts val="0"/>
+              </a:spcBef>
+              <a:spcAft>
+                <a:spcPts val="0"/>
+              </a:spcAft>
+              <a:buNone/>
+            </a:pPr>
+            <a:endParaRPr dirty="0"/>
+          </a:p>
+        </p:txBody>
+      </p:sp>
+    </p:spTree>
+  </p:cSld>
+  <p:clrMapOvr>
+    <a:masterClrMapping/>
+  </p:clrMapOvr>
+</p:notes>
+</file>
+
+<file path=ppt/notesSlides/notesSlide30.xml><?xml version="1.0" encoding="utf-8"?>
 <p:notes xmlns:a="http://schemas.openxmlformats.org/drawingml/2006/main" xmlns:r="http://schemas.openxmlformats.org/officeDocument/2006/relationships" xmlns:p="http://schemas.openxmlformats.org/presentationml/2006/main" showMasterSp="0" showMasterPhAnim="0">
   <p:cSld>
     <p:spTree>
@@ -3102,111 +3845,7 @@
 </p:notes>
 </file>
 
-<file path=ppt/notesSlides/notesSlide3.xml><?xml version="1.0" encoding="utf-8"?>
-<p:notes xmlns:a="http://schemas.openxmlformats.org/drawingml/2006/main" xmlns:r="http://schemas.openxmlformats.org/officeDocument/2006/relationships" xmlns:p="http://schemas.openxmlformats.org/presentationml/2006/main" showMasterSp="0" showMasterPhAnim="0">
-  <p:cSld>
-    <p:spTree>
-      <p:nvGrpSpPr>
-        <p:cNvPr id="1" name="Shape 60"/>
-        <p:cNvGrpSpPr/>
-        <p:nvPr/>
-      </p:nvGrpSpPr>
-      <p:grpSpPr>
-        <a:xfrm>
-          <a:off x="0" y="0"/>
-          <a:ext cx="0" cy="0"/>
-          <a:chOff x="0" y="0"/>
-          <a:chExt cx="0" cy="0"/>
-        </a:xfrm>
-      </p:grpSpPr>
-      <p:sp>
-        <p:nvSpPr>
-          <p:cNvPr id="61" name="Google Shape;61;g18401b6c2f9_0_4:notes"/>
-          <p:cNvSpPr>
-            <a:spLocks noGrp="1" noRot="1" noChangeAspect="1"/>
-          </p:cNvSpPr>
-          <p:nvPr>
-            <p:ph type="sldImg" idx="2"/>
-          </p:nvPr>
-        </p:nvSpPr>
-        <p:spPr>
-          <a:xfrm>
-            <a:off x="381300" y="685800"/>
-            <a:ext cx="6096000" cy="3429000"/>
-          </a:xfrm>
-          <a:custGeom>
-            <a:avLst/>
-            <a:gdLst/>
-            <a:ahLst/>
-            <a:cxnLst/>
-            <a:rect l="l" t="t" r="r" b="b"/>
-            <a:pathLst>
-              <a:path w="120000" h="120000" extrusionOk="0">
-                <a:moveTo>
-                  <a:pt x="0" y="0"/>
-                </a:moveTo>
-                <a:lnTo>
-                  <a:pt x="120000" y="0"/>
-                </a:lnTo>
-                <a:lnTo>
-                  <a:pt x="120000" y="120000"/>
-                </a:lnTo>
-                <a:lnTo>
-                  <a:pt x="0" y="120000"/>
-                </a:lnTo>
-                <a:close/>
-              </a:path>
-            </a:pathLst>
-          </a:custGeom>
-        </p:spPr>
-      </p:sp>
-      <p:sp>
-        <p:nvSpPr>
-          <p:cNvPr id="62" name="Google Shape;62;g18401b6c2f9_0_4:notes"/>
-          <p:cNvSpPr txBox="1">
-            <a:spLocks noGrp="1"/>
-          </p:cNvSpPr>
-          <p:nvPr>
-            <p:ph type="body" idx="1"/>
-          </p:nvPr>
-        </p:nvSpPr>
-        <p:spPr>
-          <a:xfrm>
-            <a:off x="685800" y="4343400"/>
-            <a:ext cx="5486400" cy="4114800"/>
-          </a:xfrm>
-          <a:prstGeom prst="rect">
-            <a:avLst/>
-          </a:prstGeom>
-        </p:spPr>
-        <p:txBody>
-          <a:bodyPr spcFirstLastPara="1" wrap="square" lIns="91425" tIns="91425" rIns="91425" bIns="91425" anchor="t" anchorCtr="0">
-            <a:noAutofit/>
-          </a:bodyPr>
-          <a:lstStyle/>
-          <a:p>
-            <a:pPr marL="0" lvl="0" indent="0" algn="l" rtl="0">
-              <a:spcBef>
-                <a:spcPts val="0"/>
-              </a:spcBef>
-              <a:spcAft>
-                <a:spcPts val="0"/>
-              </a:spcAft>
-              <a:buNone/>
-            </a:pPr>
-            <a:endParaRPr/>
-          </a:p>
-        </p:txBody>
-      </p:sp>
-    </p:spTree>
-  </p:cSld>
-  <p:clrMapOvr>
-    <a:masterClrMapping/>
-  </p:clrMapOvr>
-</p:notes>
-</file>
-
-<file path=ppt/notesSlides/notesSlide30.xml><?xml version="1.0" encoding="utf-8"?>
+<file path=ppt/notesSlides/notesSlide31.xml><?xml version="1.0" encoding="utf-8"?>
 <p:notes xmlns:a="http://schemas.openxmlformats.org/drawingml/2006/main" xmlns:r="http://schemas.openxmlformats.org/officeDocument/2006/relationships" xmlns:p="http://schemas.openxmlformats.org/presentationml/2006/main" showMasterSp="0" showMasterPhAnim="0">
   <p:cSld>
     <p:spTree>
@@ -3314,7 +3953,7 @@
 </p:notes>
 </file>
 
-<file path=ppt/notesSlides/notesSlide31.xml><?xml version="1.0" encoding="utf-8"?>
+<file path=ppt/notesSlides/notesSlide32.xml><?xml version="1.0" encoding="utf-8"?>
 <p:notes xmlns:a="http://schemas.openxmlformats.org/drawingml/2006/main" xmlns:r="http://schemas.openxmlformats.org/officeDocument/2006/relationships" xmlns:p="http://schemas.openxmlformats.org/presentationml/2006/main" showMasterSp="0" showMasterPhAnim="0">
   <p:cSld>
     <p:spTree>
@@ -3343,7 +3982,7 @@
         </p:nvSpPr>
         <p:spPr>
           <a:xfrm>
-            <a:off x="381300" y="685800"/>
+            <a:off x="381000" y="685800"/>
             <a:ext cx="6096000" cy="3429000"/>
           </a:xfrm>
           <a:custGeom>
@@ -3412,14 +4051,14 @@
               <a:buNone/>
             </a:pPr>
             <a:r>
-              <a:rPr lang="en">
+              <a:rPr lang="en" dirty="0">
                 <a:solidFill>
                   <a:schemeClr val="dk1"/>
                 </a:solidFill>
               </a:rPr>
               <a:t>login/</a:t>
             </a:r>
-            <a:endParaRPr>
+            <a:endParaRPr dirty="0">
               <a:solidFill>
                 <a:schemeClr val="dk1"/>
               </a:solidFill>
@@ -3436,10 +4075,37 @@
               <a:buNone/>
             </a:pPr>
             <a:r>
-              <a:rPr lang="en"/>
+              <a:rPr lang="en" dirty="0"/>
               <a:t>store/</a:t>
             </a:r>
-            <a:endParaRPr/>
+          </a:p>
+          <a:p>
+            <a:pPr marL="0" lvl="0" indent="0" algn="l" rtl="0">
+              <a:spcBef>
+                <a:spcPts val="0"/>
+              </a:spcBef>
+              <a:spcAft>
+                <a:spcPts val="0"/>
+              </a:spcAft>
+              <a:buNone/>
+            </a:pPr>
+            <a:endParaRPr lang="en" dirty="0"/>
+          </a:p>
+          <a:p>
+            <a:pPr marL="0" lvl="0" indent="0" algn="l" rtl="0">
+              <a:spcBef>
+                <a:spcPts val="0"/>
+              </a:spcBef>
+              <a:spcAft>
+                <a:spcPts val="0"/>
+              </a:spcAft>
+              <a:buNone/>
+            </a:pPr>
+            <a:r>
+              <a:rPr lang="en" dirty="0"/>
+              <a:t>Session keeps track of whether the page has “seen” someone before</a:t>
+            </a:r>
+            <a:endParaRPr dirty="0"/>
           </a:p>
         </p:txBody>
       </p:sp>
@@ -3451,7 +4117,7 @@
 </p:notes>
 </file>
 
-<file path=ppt/notesSlides/notesSlide32.xml><?xml version="1.0" encoding="utf-8"?>
+<file path=ppt/notesSlides/notesSlide33.xml><?xml version="1.0" encoding="utf-8"?>
 <p:notes xmlns:a="http://schemas.openxmlformats.org/drawingml/2006/main" xmlns:r="http://schemas.openxmlformats.org/officeDocument/2006/relationships" xmlns:p="http://schemas.openxmlformats.org/presentationml/2006/main" showMasterSp="0" showMasterPhAnim="0">
   <p:cSld>
     <p:spTree>
@@ -3559,7 +4225,7 @@
 </p:notes>
 </file>
 
-<file path=ppt/notesSlides/notesSlide33.xml><?xml version="1.0" encoding="utf-8"?>
+<file path=ppt/notesSlides/notesSlide34.xml><?xml version="1.0" encoding="utf-8"?>
 <p:notes xmlns:a="http://schemas.openxmlformats.org/drawingml/2006/main" xmlns:r="http://schemas.openxmlformats.org/officeDocument/2006/relationships" xmlns:p="http://schemas.openxmlformats.org/presentationml/2006/main" showMasterSp="0" showMasterPhAnim="0">
   <p:cSld>
     <p:spTree>
@@ -3588,7 +4254,7 @@
         </p:nvSpPr>
         <p:spPr>
           <a:xfrm>
-            <a:off x="381300" y="685800"/>
+            <a:off x="381000" y="685800"/>
             <a:ext cx="6096000" cy="3429000"/>
           </a:xfrm>
           <a:custGeom>
@@ -3652,10 +4318,37 @@
               <a:buNone/>
             </a:pPr>
             <a:r>
-              <a:rPr lang="en"/>
+              <a:rPr lang="en" dirty="0"/>
               <a:t>shows2/</a:t>
             </a:r>
-            <a:endParaRPr/>
+          </a:p>
+          <a:p>
+            <a:pPr marL="0" lvl="0" indent="0" algn="l" rtl="0">
+              <a:spcBef>
+                <a:spcPts val="0"/>
+              </a:spcBef>
+              <a:spcAft>
+                <a:spcPts val="0"/>
+              </a:spcAft>
+              <a:buNone/>
+            </a:pPr>
+            <a:endParaRPr lang="en" dirty="0"/>
+          </a:p>
+          <a:p>
+            <a:pPr marL="0" lvl="0" indent="0" algn="l" rtl="0">
+              <a:spcBef>
+                <a:spcPts val="0"/>
+              </a:spcBef>
+              <a:spcAft>
+                <a:spcPts val="0"/>
+              </a:spcAft>
+              <a:buNone/>
+            </a:pPr>
+            <a:r>
+              <a:rPr lang="en" dirty="0"/>
+              <a:t>Protocol to send back snippets, e.g. from a search</a:t>
+            </a:r>
+            <a:endParaRPr dirty="0"/>
           </a:p>
         </p:txBody>
       </p:sp>
@@ -3667,7 +4360,7 @@
 </p:notes>
 </file>
 
-<file path=ppt/notesSlides/notesSlide34.xml><?xml version="1.0" encoding="utf-8"?>
+<file path=ppt/notesSlides/notesSlide35.xml><?xml version="1.0" encoding="utf-8"?>
 <p:notes xmlns:a="http://schemas.openxmlformats.org/drawingml/2006/main" xmlns:r="http://schemas.openxmlformats.org/officeDocument/2006/relationships" xmlns:p="http://schemas.openxmlformats.org/presentationml/2006/main" showMasterSp="0" showMasterPhAnim="0">
   <p:cSld>
     <p:spTree>
@@ -3696,7 +4389,7 @@
         </p:nvSpPr>
         <p:spPr>
           <a:xfrm>
-            <a:off x="381300" y="685800"/>
+            <a:off x="381000" y="685800"/>
             <a:ext cx="6096000" cy="3429000"/>
           </a:xfrm>
           <a:custGeom>
@@ -3759,7 +4452,81 @@
               </a:spcAft>
               <a:buNone/>
             </a:pPr>
-            <a:endParaRPr/>
+            <a:r>
+              <a:rPr lang="en-GB" dirty="0"/>
+              <a:t>JSON </a:t>
+            </a:r>
+            <a:r>
+              <a:rPr lang="en-GB" dirty="0" err="1"/>
+              <a:t>Javascript</a:t>
+            </a:r>
+            <a:r>
+              <a:rPr lang="en-GB" dirty="0"/>
+              <a:t> Object Notation</a:t>
+            </a:r>
+          </a:p>
+          <a:p>
+            <a:pPr marL="0" lvl="0" indent="0" algn="l" rtl="0">
+              <a:spcBef>
+                <a:spcPts val="0"/>
+              </a:spcBef>
+              <a:spcAft>
+                <a:spcPts val="0"/>
+              </a:spcAft>
+              <a:buNone/>
+            </a:pPr>
+            <a:endParaRPr lang="en-GB" dirty="0"/>
+          </a:p>
+          <a:p>
+            <a:pPr marL="0" lvl="0" indent="0" algn="l" rtl="0">
+              <a:spcBef>
+                <a:spcPts val="0"/>
+              </a:spcBef>
+              <a:spcAft>
+                <a:spcPts val="0"/>
+              </a:spcAft>
+              <a:buNone/>
+            </a:pPr>
+            <a:r>
+              <a:rPr lang="en-GB" dirty="0"/>
+              <a:t>Kind of like a code dictionary</a:t>
+            </a:r>
+          </a:p>
+          <a:p>
+            <a:pPr marL="0" lvl="0" indent="0" algn="l" rtl="0">
+              <a:spcBef>
+                <a:spcPts val="0"/>
+              </a:spcBef>
+              <a:spcAft>
+                <a:spcPts val="0"/>
+              </a:spcAft>
+              <a:buNone/>
+            </a:pPr>
+            <a:endParaRPr lang="en-GB" dirty="0"/>
+          </a:p>
+          <a:p>
+            <a:pPr marL="0" lvl="0" indent="0" algn="l" rtl="0">
+              <a:spcBef>
+                <a:spcPts val="0"/>
+              </a:spcBef>
+              <a:spcAft>
+                <a:spcPts val="0"/>
+              </a:spcAft>
+              <a:buNone/>
+            </a:pPr>
+            <a:r>
+              <a:rPr lang="en-GB" dirty="0"/>
+              <a:t>Import “</a:t>
+            </a:r>
+            <a:r>
+              <a:rPr lang="en-GB" dirty="0" err="1"/>
+              <a:t>jasonify</a:t>
+            </a:r>
+            <a:r>
+              <a:rPr lang="en-GB" dirty="0"/>
+              <a:t>”</a:t>
+            </a:r>
+            <a:endParaRPr dirty="0"/>
           </a:p>
         </p:txBody>
       </p:sp>
@@ -3771,7 +4538,7 @@
 </p:notes>
 </file>
 
-<file path=ppt/notesSlides/notesSlide35.xml><?xml version="1.0" encoding="utf-8"?>
+<file path=ppt/notesSlides/notesSlide36.xml><?xml version="1.0" encoding="utf-8"?>
 <p:notes xmlns:a="http://schemas.openxmlformats.org/drawingml/2006/main" xmlns:r="http://schemas.openxmlformats.org/officeDocument/2006/relationships" xmlns:p="http://schemas.openxmlformats.org/presentationml/2006/main" showMasterSp="0" showMasterPhAnim="0">
   <p:cSld>
     <p:spTree>
@@ -3879,7 +4646,7 @@
 </p:notes>
 </file>
 
-<file path=ppt/notesSlides/notesSlide36.xml><?xml version="1.0" encoding="utf-8"?>
+<file path=ppt/notesSlides/notesSlide37.xml><?xml version="1.0" encoding="utf-8"?>
 <p:notes xmlns:a="http://schemas.openxmlformats.org/drawingml/2006/main" xmlns:r="http://schemas.openxmlformats.org/officeDocument/2006/relationships" xmlns:p="http://schemas.openxmlformats.org/presentationml/2006/main" showMasterSp="0" showMasterPhAnim="0">
   <p:cSld>
     <p:spTree>
@@ -4016,7 +4783,7 @@
         </p:nvSpPr>
         <p:spPr>
           <a:xfrm>
-            <a:off x="381300" y="685800"/>
+            <a:off x="381000" y="685800"/>
             <a:ext cx="6096000" cy="3429000"/>
           </a:xfrm>
           <a:custGeom>
@@ -4079,7 +4846,11 @@
               </a:spcAft>
               <a:buNone/>
             </a:pPr>
-            <a:endParaRPr/>
+            <a:r>
+              <a:rPr lang="en-GB" dirty="0"/>
+              <a:t>Specify a specific file</a:t>
+            </a:r>
+            <a:endParaRPr dirty="0"/>
           </a:p>
         </p:txBody>
       </p:sp>
@@ -4120,7 +4891,7 @@
         </p:nvSpPr>
         <p:spPr>
           <a:xfrm>
-            <a:off x="381300" y="685800"/>
+            <a:off x="381000" y="685800"/>
             <a:ext cx="6096000" cy="3429000"/>
           </a:xfrm>
           <a:custGeom>
@@ -4183,7 +4954,11 @@
               </a:spcAft>
               <a:buNone/>
             </a:pPr>
-            <a:endParaRPr/>
+            <a:r>
+              <a:rPr lang="en-GB" dirty="0"/>
+              <a:t>Specific folder</a:t>
+            </a:r>
+            <a:endParaRPr dirty="0"/>
           </a:p>
         </p:txBody>
       </p:sp>
@@ -4224,7 +4999,7 @@
         </p:nvSpPr>
         <p:spPr>
           <a:xfrm>
-            <a:off x="381300" y="685800"/>
+            <a:off x="381000" y="685800"/>
             <a:ext cx="6096000" cy="3429000"/>
           </a:xfrm>
           <a:custGeom>
@@ -4287,7 +5062,11 @@
               </a:spcAft>
               <a:buNone/>
             </a:pPr>
-            <a:endParaRPr/>
+            <a:r>
+              <a:rPr lang="en-GB" dirty="0"/>
+              <a:t>File in a folder</a:t>
+            </a:r>
+            <a:endParaRPr dirty="0"/>
           </a:p>
         </p:txBody>
       </p:sp>
@@ -4328,7 +5107,7 @@
         </p:nvSpPr>
         <p:spPr>
           <a:xfrm>
-            <a:off x="381300" y="685800"/>
+            <a:off x="381000" y="685800"/>
             <a:ext cx="6096000" cy="3429000"/>
           </a:xfrm>
           <a:custGeom>
@@ -4391,7 +5170,11 @@
               </a:spcAft>
               <a:buNone/>
             </a:pPr>
-            <a:endParaRPr/>
+            <a:r>
+              <a:rPr lang="en-GB" dirty="0"/>
+              <a:t>“the path” specifying a folder/file etc</a:t>
+            </a:r>
+            <a:endParaRPr dirty="0"/>
           </a:p>
         </p:txBody>
       </p:sp>
@@ -4432,7 +5215,7 @@
         </p:nvSpPr>
         <p:spPr>
           <a:xfrm>
-            <a:off x="381300" y="685800"/>
+            <a:off x="381000" y="685800"/>
             <a:ext cx="6096000" cy="3429000"/>
           </a:xfrm>
           <a:custGeom>
@@ -4495,7 +5278,11 @@
               </a:spcAft>
               <a:buNone/>
             </a:pPr>
-            <a:endParaRPr/>
+            <a:r>
+              <a:rPr lang="en-GB" dirty="0"/>
+              <a:t>Specify a “route” – what path do you select on the server?</a:t>
+            </a:r>
+            <a:endParaRPr dirty="0"/>
           </a:p>
         </p:txBody>
       </p:sp>
@@ -4536,7 +5323,7 @@
         </p:nvSpPr>
         <p:spPr>
           <a:xfrm>
-            <a:off x="381300" y="685800"/>
+            <a:off x="381000" y="685800"/>
             <a:ext cx="6096000" cy="3429000"/>
           </a:xfrm>
           <a:custGeom>
@@ -4599,7 +5386,11 @@
               </a:spcAft>
               <a:buNone/>
             </a:pPr>
-            <a:endParaRPr/>
+            <a:r>
+              <a:rPr lang="en-GB" dirty="0"/>
+              <a:t>Introducing a key values – implement the “back end” for specifying inputs</a:t>
+            </a:r>
+            <a:endParaRPr dirty="0"/>
           </a:p>
         </p:txBody>
       </p:sp>
@@ -11020,7 +11811,7 @@
               <a:buNone/>
             </a:pPr>
             <a:r>
-              <a:rPr lang="en">
+              <a:rPr lang="en" dirty="0">
                 <a:solidFill>
                   <a:srgbClr val="FFFFFF"/>
                 </a:solidFill>
@@ -11031,7 +11822,7 @@
               </a:rPr>
               <a:t>request.args</a:t>
             </a:r>
-            <a:endParaRPr>
+            <a:endParaRPr dirty="0">
               <a:solidFill>
                 <a:srgbClr val="FFFFFF"/>
               </a:solidFill>
@@ -11043,6 +11834,36 @@
           </a:p>
         </p:txBody>
       </p:sp>
+      <p:pic>
+        <p:nvPicPr>
+          <p:cNvPr id="5" name="Picture 4">
+            <a:extLst>
+              <a:ext uri="{FF2B5EF4-FFF2-40B4-BE49-F238E27FC236}">
+                <a16:creationId xmlns:a16="http://schemas.microsoft.com/office/drawing/2014/main" id="{4CDED859-173E-D30B-7ECC-94B3868AFF91}"/>
+              </a:ext>
+            </a:extLst>
+          </p:cNvPr>
+          <p:cNvPicPr>
+            <a:picLocks noChangeAspect="1"/>
+          </p:cNvPicPr>
+          <p:nvPr/>
+        </p:nvPicPr>
+        <p:blipFill>
+          <a:blip r:embed="rId3"/>
+          <a:stretch>
+            <a:fillRect/>
+          </a:stretch>
+        </p:blipFill>
+        <p:spPr>
+          <a:xfrm>
+            <a:off x="2075450" y="938834"/>
+            <a:ext cx="6756850" cy="3148014"/>
+          </a:xfrm>
+          <a:prstGeom prst="rect">
+            <a:avLst/>
+          </a:prstGeom>
+        </p:spPr>
+      </p:pic>
     </p:spTree>
   </p:cSld>
   <p:clrMapOvr>
@@ -11056,7 +11877,13 @@
   <p:cSld>
     <p:spTree>
       <p:nvGrpSpPr>
-        <p:cNvPr id="1" name="Shape 143"/>
+        <p:cNvPr id="1" name="Shape 138">
+          <a:extLst>
+            <a:ext uri="{FF2B5EF4-FFF2-40B4-BE49-F238E27FC236}">
+              <a16:creationId xmlns:a16="http://schemas.microsoft.com/office/drawing/2014/main" id="{F71B661E-4385-3917-DB44-71E1AB11862E}"/>
+            </a:ext>
+          </a:extLst>
+        </p:cNvPr>
         <p:cNvGrpSpPr/>
         <p:nvPr/>
       </p:nvGrpSpPr>
@@ -11070,18 +11897,24 @@
       </p:grpSpPr>
       <p:sp>
         <p:nvSpPr>
-          <p:cNvPr id="144" name="Google Shape;144;p31"/>
+          <p:cNvPr id="4" name="Google Shape;139;p30">
+            <a:extLst>
+              <a:ext uri="{FF2B5EF4-FFF2-40B4-BE49-F238E27FC236}">
+                <a16:creationId xmlns:a16="http://schemas.microsoft.com/office/drawing/2014/main" id="{7F731989-7FCD-4A49-DC76-51A4FAC68E54}"/>
+              </a:ext>
+            </a:extLst>
+          </p:cNvPr>
           <p:cNvSpPr txBox="1">
             <a:spLocks noGrp="1"/>
           </p:cNvSpPr>
           <p:nvPr>
-            <p:ph type="title"/>
+            <p:ph type="body" idx="1"/>
           </p:nvPr>
         </p:nvSpPr>
         <p:spPr>
           <a:xfrm>
-            <a:off x="311700" y="2150850"/>
-            <a:ext cx="8520600" cy="841800"/>
+            <a:off x="311700" y="1152475"/>
+            <a:ext cx="8520600" cy="3416400"/>
           </a:xfrm>
           <a:prstGeom prst="rect">
             <a:avLst/>
@@ -11093,7 +11926,7 @@
           </a:bodyPr>
           <a:lstStyle/>
           <a:p>
-            <a:pPr marL="0" lvl="0" indent="0" algn="ctr" rtl="0">
+            <a:pPr marL="0" lvl="0" indent="0" algn="l" rtl="0">
               <a:spcBef>
                 <a:spcPts val="0"/>
               </a:spcBef>
@@ -11103,14 +11936,95 @@
               <a:buNone/>
             </a:pPr>
             <a:r>
-              <a:rPr lang="en"/>
-              <a:t>Jinja</a:t>
+              <a:rPr lang="en" dirty="0">
+                <a:solidFill>
+                  <a:srgbClr val="FFFFFF"/>
+                </a:solidFill>
+                <a:latin typeface="Consolas"/>
+                <a:ea typeface="Consolas"/>
+                <a:cs typeface="Consolas"/>
+                <a:sym typeface="Consolas"/>
+              </a:rPr>
+              <a:t>forms</a:t>
             </a:r>
-            <a:endParaRPr/>
+            <a:endParaRPr dirty="0">
+              <a:solidFill>
+                <a:srgbClr val="FFFFFF"/>
+              </a:solidFill>
+              <a:latin typeface="Consolas"/>
+              <a:ea typeface="Consolas"/>
+              <a:cs typeface="Consolas"/>
+              <a:sym typeface="Consolas"/>
+            </a:endParaRPr>
           </a:p>
         </p:txBody>
       </p:sp>
+      <p:pic>
+        <p:nvPicPr>
+          <p:cNvPr id="7" name="Picture 6">
+            <a:extLst>
+              <a:ext uri="{FF2B5EF4-FFF2-40B4-BE49-F238E27FC236}">
+                <a16:creationId xmlns:a16="http://schemas.microsoft.com/office/drawing/2014/main" id="{E77391EB-8B66-54EE-DC14-3069D68D8E3C}"/>
+              </a:ext>
+            </a:extLst>
+          </p:cNvPr>
+          <p:cNvPicPr>
+            <a:picLocks noChangeAspect="1"/>
+          </p:cNvPicPr>
+          <p:nvPr/>
+        </p:nvPicPr>
+        <p:blipFill>
+          <a:blip r:embed="rId3"/>
+          <a:stretch>
+            <a:fillRect/>
+          </a:stretch>
+        </p:blipFill>
+        <p:spPr>
+          <a:xfrm>
+            <a:off x="421432" y="231320"/>
+            <a:ext cx="3656204" cy="2261027"/>
+          </a:xfrm>
+          <a:prstGeom prst="rect">
+            <a:avLst/>
+          </a:prstGeom>
+        </p:spPr>
+      </p:pic>
+      <p:pic>
+        <p:nvPicPr>
+          <p:cNvPr id="9" name="Picture 8">
+            <a:extLst>
+              <a:ext uri="{FF2B5EF4-FFF2-40B4-BE49-F238E27FC236}">
+                <a16:creationId xmlns:a16="http://schemas.microsoft.com/office/drawing/2014/main" id="{3A3433C0-01A4-0D3B-3BE4-B520D05B8444}"/>
+              </a:ext>
+            </a:extLst>
+          </p:cNvPr>
+          <p:cNvPicPr>
+            <a:picLocks noChangeAspect="1"/>
+          </p:cNvPicPr>
+          <p:nvPr/>
+        </p:nvPicPr>
+        <p:blipFill>
+          <a:blip r:embed="rId4"/>
+          <a:stretch>
+            <a:fillRect/>
+          </a:stretch>
+        </p:blipFill>
+        <p:spPr>
+          <a:xfrm>
+            <a:off x="2298471" y="2129638"/>
+            <a:ext cx="6643561" cy="2801946"/>
+          </a:xfrm>
+          <a:prstGeom prst="rect">
+            <a:avLst/>
+          </a:prstGeom>
+        </p:spPr>
+      </p:pic>
     </p:spTree>
+    <p:extLst>
+      <p:ext uri="{BB962C8B-B14F-4D97-AF65-F5344CB8AC3E}">
+        <p14:creationId xmlns:p14="http://schemas.microsoft.com/office/powerpoint/2010/main" val="367760008"/>
+      </p:ext>
+    </p:extLst>
   </p:cSld>
   <p:clrMapOvr>
     <a:masterClrMapping/>
@@ -11206,6 +12120,73 @@
   <p:cSld>
     <p:spTree>
       <p:nvGrpSpPr>
+        <p:cNvPr id="1" name="Shape 143"/>
+        <p:cNvGrpSpPr/>
+        <p:nvPr/>
+      </p:nvGrpSpPr>
+      <p:grpSpPr>
+        <a:xfrm>
+          <a:off x="0" y="0"/>
+          <a:ext cx="0" cy="0"/>
+          <a:chOff x="0" y="0"/>
+          <a:chExt cx="0" cy="0"/>
+        </a:xfrm>
+      </p:grpSpPr>
+      <p:sp>
+        <p:nvSpPr>
+          <p:cNvPr id="144" name="Google Shape;144;p31"/>
+          <p:cNvSpPr txBox="1">
+            <a:spLocks noGrp="1"/>
+          </p:cNvSpPr>
+          <p:nvPr>
+            <p:ph type="title"/>
+          </p:nvPr>
+        </p:nvSpPr>
+        <p:spPr>
+          <a:xfrm>
+            <a:off x="311700" y="2150850"/>
+            <a:ext cx="8520600" cy="841800"/>
+          </a:xfrm>
+          <a:prstGeom prst="rect">
+            <a:avLst/>
+          </a:prstGeom>
+        </p:spPr>
+        <p:txBody>
+          <a:bodyPr spcFirstLastPara="1" wrap="square" lIns="91425" tIns="91425" rIns="91425" bIns="91425" anchor="ctr" anchorCtr="0">
+            <a:noAutofit/>
+          </a:bodyPr>
+          <a:lstStyle/>
+          <a:p>
+            <a:pPr marL="0" lvl="0" indent="0" algn="ctr" rtl="0">
+              <a:spcBef>
+                <a:spcPts val="0"/>
+              </a:spcBef>
+              <a:spcAft>
+                <a:spcPts val="0"/>
+              </a:spcAft>
+              <a:buNone/>
+            </a:pPr>
+            <a:r>
+              <a:rPr lang="en"/>
+              <a:t>Jinja</a:t>
+            </a:r>
+            <a:endParaRPr/>
+          </a:p>
+        </p:txBody>
+      </p:sp>
+    </p:spTree>
+  </p:cSld>
+  <p:clrMapOvr>
+    <a:masterClrMapping/>
+  </p:clrMapOvr>
+</p:sld>
+</file>
+
+<file path=ppt/slides/slide21.xml><?xml version="1.0" encoding="utf-8"?>
+<p:sld xmlns:a="http://schemas.openxmlformats.org/drawingml/2006/main" xmlns:r="http://schemas.openxmlformats.org/officeDocument/2006/relationships" xmlns:p="http://schemas.openxmlformats.org/presentationml/2006/main">
+  <p:cSld>
+    <p:spTree>
+      <p:nvGrpSpPr>
         <p:cNvPr id="1" name="Shape 148"/>
         <p:cNvGrpSpPr/>
         <p:nvPr/>
@@ -11284,7 +12265,7 @@
 </p:sld>
 </file>
 
-<file path=ppt/slides/slide21.xml><?xml version="1.0" encoding="utf-8"?>
+<file path=ppt/slides/slide22.xml><?xml version="1.0" encoding="utf-8"?>
 <p:sld xmlns:a="http://schemas.openxmlformats.org/drawingml/2006/main" xmlns:r="http://schemas.openxmlformats.org/officeDocument/2006/relationships" xmlns:p="http://schemas.openxmlformats.org/presentationml/2006/main">
   <p:cSld>
     <p:spTree>
@@ -11360,7 +12341,7 @@
 </p:sld>
 </file>
 
-<file path=ppt/slides/slide22.xml><?xml version="1.0" encoding="utf-8"?>
+<file path=ppt/slides/slide23.xml><?xml version="1.0" encoding="utf-8"?>
 <p:sld xmlns:a="http://schemas.openxmlformats.org/drawingml/2006/main" xmlns:r="http://schemas.openxmlformats.org/officeDocument/2006/relationships" xmlns:p="http://schemas.openxmlformats.org/presentationml/2006/main">
   <p:cSld>
     <p:bg>
@@ -11461,7 +12442,7 @@
 </p:sld>
 </file>
 
-<file path=ppt/slides/slide23.xml><?xml version="1.0" encoding="utf-8"?>
+<file path=ppt/slides/slide24.xml><?xml version="1.0" encoding="utf-8"?>
 <p:sld xmlns:a="http://schemas.openxmlformats.org/drawingml/2006/main" xmlns:r="http://schemas.openxmlformats.org/officeDocument/2006/relationships" xmlns:p="http://schemas.openxmlformats.org/presentationml/2006/main">
   <p:cSld>
     <p:spTree>
@@ -11749,7 +12730,7 @@
 </p:sld>
 </file>
 
-<file path=ppt/slides/slide24.xml><?xml version="1.0" encoding="utf-8"?>
+<file path=ppt/slides/slide25.xml><?xml version="1.0" encoding="utf-8"?>
 <p:sld xmlns:a="http://schemas.openxmlformats.org/drawingml/2006/main" xmlns:r="http://schemas.openxmlformats.org/officeDocument/2006/relationships" xmlns:p="http://schemas.openxmlformats.org/presentationml/2006/main">
   <p:cSld>
     <p:spTree>
@@ -12121,7 +13102,7 @@
 </p:sld>
 </file>
 
-<file path=ppt/slides/slide25.xml><?xml version="1.0" encoding="utf-8"?>
+<file path=ppt/slides/slide26.xml><?xml version="1.0" encoding="utf-8"?>
 <p:sld xmlns:a="http://schemas.openxmlformats.org/drawingml/2006/main" xmlns:r="http://schemas.openxmlformats.org/officeDocument/2006/relationships" xmlns:p="http://schemas.openxmlformats.org/presentationml/2006/main">
   <p:cSld>
     <p:spTree>
@@ -12174,7 +13155,7 @@
 </p:sld>
 </file>
 
-<file path=ppt/slides/slide26.xml><?xml version="1.0" encoding="utf-8"?>
+<file path=ppt/slides/slide27.xml><?xml version="1.0" encoding="utf-8"?>
 <p:sld xmlns:a="http://schemas.openxmlformats.org/drawingml/2006/main" xmlns:r="http://schemas.openxmlformats.org/officeDocument/2006/relationships" xmlns:p="http://schemas.openxmlformats.org/presentationml/2006/main">
   <p:cSld>
     <p:spTree>
@@ -12341,7 +13322,7 @@
 </p:sld>
 </file>
 
-<file path=ppt/slides/slide27.xml><?xml version="1.0" encoding="utf-8"?>
+<file path=ppt/slides/slide28.xml><?xml version="1.0" encoding="utf-8"?>
 <p:sld xmlns:a="http://schemas.openxmlformats.org/drawingml/2006/main" xmlns:r="http://schemas.openxmlformats.org/officeDocument/2006/relationships" xmlns:p="http://schemas.openxmlformats.org/presentationml/2006/main">
   <p:cSld>
     <p:spTree>
@@ -12508,7 +13489,7 @@
 </p:sld>
 </file>
 
-<file path=ppt/slides/slide28.xml><?xml version="1.0" encoding="utf-8"?>
+<file path=ppt/slides/slide29.xml><?xml version="1.0" encoding="utf-8"?>
 <p:sld xmlns:a="http://schemas.openxmlformats.org/drawingml/2006/main" xmlns:r="http://schemas.openxmlformats.org/officeDocument/2006/relationships" xmlns:p="http://schemas.openxmlformats.org/presentationml/2006/main">
   <p:cSld>
     <p:spTree>
@@ -12635,173 +13616,6 @@
               </a:rPr>
               <a:t>Set-Cookie: session=value</a:t>
             </a:r>
-            <a:endParaRPr>
-              <a:solidFill>
-                <a:srgbClr val="FFFFFF"/>
-              </a:solidFill>
-              <a:latin typeface="Consolas"/>
-              <a:ea typeface="Consolas"/>
-              <a:cs typeface="Consolas"/>
-              <a:sym typeface="Consolas"/>
-            </a:endParaRPr>
-          </a:p>
-          <a:p>
-            <a:pPr marL="0" lvl="0" indent="0" algn="l" rtl="0">
-              <a:spcBef>
-                <a:spcPts val="0"/>
-              </a:spcBef>
-              <a:spcAft>
-                <a:spcPts val="0"/>
-              </a:spcAft>
-              <a:buNone/>
-            </a:pPr>
-            <a:r>
-              <a:rPr lang="en">
-                <a:solidFill>
-                  <a:srgbClr val="FFFFFF"/>
-                </a:solidFill>
-                <a:latin typeface="Consolas"/>
-                <a:ea typeface="Consolas"/>
-                <a:cs typeface="Consolas"/>
-                <a:sym typeface="Consolas"/>
-              </a:rPr>
-              <a:t>...</a:t>
-            </a:r>
-            <a:endParaRPr>
-              <a:solidFill>
-                <a:srgbClr val="FFFFFF"/>
-              </a:solidFill>
-              <a:latin typeface="Consolas"/>
-              <a:ea typeface="Consolas"/>
-              <a:cs typeface="Consolas"/>
-              <a:sym typeface="Consolas"/>
-            </a:endParaRPr>
-          </a:p>
-        </p:txBody>
-      </p:sp>
-    </p:spTree>
-  </p:cSld>
-  <p:clrMapOvr>
-    <a:masterClrMapping/>
-  </p:clrMapOvr>
-</p:sld>
-</file>
-
-<file path=ppt/slides/slide29.xml><?xml version="1.0" encoding="utf-8"?>
-<p:sld xmlns:a="http://schemas.openxmlformats.org/drawingml/2006/main" xmlns:r="http://schemas.openxmlformats.org/officeDocument/2006/relationships" xmlns:p="http://schemas.openxmlformats.org/presentationml/2006/main">
-  <p:cSld>
-    <p:spTree>
-      <p:nvGrpSpPr>
-        <p:cNvPr id="1" name="Shape 206"/>
-        <p:cNvGrpSpPr/>
-        <p:nvPr/>
-      </p:nvGrpSpPr>
-      <p:grpSpPr>
-        <a:xfrm>
-          <a:off x="0" y="0"/>
-          <a:ext cx="0" cy="0"/>
-          <a:chOff x="0" y="0"/>
-          <a:chExt cx="0" cy="0"/>
-        </a:xfrm>
-      </p:grpSpPr>
-      <p:sp>
-        <p:nvSpPr>
-          <p:cNvPr id="207" name="Google Shape;207;p41"/>
-          <p:cNvSpPr txBox="1">
-            <a:spLocks noGrp="1"/>
-          </p:cNvSpPr>
-          <p:nvPr>
-            <p:ph type="body" idx="1"/>
-          </p:nvPr>
-        </p:nvSpPr>
-        <p:spPr>
-          <a:xfrm>
-            <a:off x="311700" y="1152475"/>
-            <a:ext cx="8520600" cy="3416400"/>
-          </a:xfrm>
-          <a:prstGeom prst="rect">
-            <a:avLst/>
-          </a:prstGeom>
-        </p:spPr>
-        <p:txBody>
-          <a:bodyPr spcFirstLastPara="1" wrap="square" lIns="91425" tIns="91425" rIns="91425" bIns="91425" anchor="ctr" anchorCtr="0">
-            <a:noAutofit/>
-          </a:bodyPr>
-          <a:lstStyle/>
-          <a:p>
-            <a:pPr marL="0" lvl="0" indent="0" algn="l" rtl="0">
-              <a:spcBef>
-                <a:spcPts val="0"/>
-              </a:spcBef>
-              <a:spcAft>
-                <a:spcPts val="0"/>
-              </a:spcAft>
-              <a:buNone/>
-            </a:pPr>
-            <a:r>
-              <a:rPr lang="en">
-                <a:solidFill>
-                  <a:srgbClr val="FFFFFF"/>
-                </a:solidFill>
-                <a:latin typeface="Consolas"/>
-                <a:ea typeface="Consolas"/>
-                <a:cs typeface="Consolas"/>
-                <a:sym typeface="Consolas"/>
-              </a:rPr>
-              <a:t>GET / HTTP/2</a:t>
-            </a:r>
-            <a:endParaRPr>
-              <a:solidFill>
-                <a:srgbClr val="FFFFFF"/>
-              </a:solidFill>
-              <a:latin typeface="Consolas"/>
-              <a:ea typeface="Consolas"/>
-              <a:cs typeface="Consolas"/>
-              <a:sym typeface="Consolas"/>
-            </a:endParaRPr>
-          </a:p>
-          <a:p>
-            <a:pPr marL="0" lvl="0" indent="0" algn="l" rtl="0">
-              <a:spcBef>
-                <a:spcPts val="0"/>
-              </a:spcBef>
-              <a:spcAft>
-                <a:spcPts val="0"/>
-              </a:spcAft>
-              <a:buNone/>
-            </a:pPr>
-            <a:r>
-              <a:rPr lang="en">
-                <a:solidFill>
-                  <a:srgbClr val="FFFFFF"/>
-                </a:solidFill>
-                <a:latin typeface="Consolas"/>
-                <a:ea typeface="Consolas"/>
-                <a:cs typeface="Consolas"/>
-                <a:sym typeface="Consolas"/>
-              </a:rPr>
-              <a:t>Host: accounts.google.com</a:t>
-            </a:r>
-            <a:endParaRPr>
-              <a:solidFill>
-                <a:srgbClr val="FFFFFF"/>
-              </a:solidFill>
-              <a:latin typeface="Consolas"/>
-              <a:ea typeface="Consolas"/>
-              <a:cs typeface="Consolas"/>
-              <a:sym typeface="Consolas"/>
-            </a:endParaRPr>
-          </a:p>
-          <a:p>
-            <a:pPr marL="0" lvl="0" indent="0" algn="l" rtl="0">
-              <a:spcBef>
-                <a:spcPts val="0"/>
-              </a:spcBef>
-              <a:spcAft>
-                <a:spcPts val="0"/>
-              </a:spcAft>
-              <a:buNone/>
-            </a:pPr>
             <a:endParaRPr>
               <a:solidFill>
                 <a:srgbClr val="FFFFFF"/>
@@ -12938,6 +13752,173 @@
   <p:cSld>
     <p:spTree>
       <p:nvGrpSpPr>
+        <p:cNvPr id="1" name="Shape 206"/>
+        <p:cNvGrpSpPr/>
+        <p:nvPr/>
+      </p:nvGrpSpPr>
+      <p:grpSpPr>
+        <a:xfrm>
+          <a:off x="0" y="0"/>
+          <a:ext cx="0" cy="0"/>
+          <a:chOff x="0" y="0"/>
+          <a:chExt cx="0" cy="0"/>
+        </a:xfrm>
+      </p:grpSpPr>
+      <p:sp>
+        <p:nvSpPr>
+          <p:cNvPr id="207" name="Google Shape;207;p41"/>
+          <p:cNvSpPr txBox="1">
+            <a:spLocks noGrp="1"/>
+          </p:cNvSpPr>
+          <p:nvPr>
+            <p:ph type="body" idx="1"/>
+          </p:nvPr>
+        </p:nvSpPr>
+        <p:spPr>
+          <a:xfrm>
+            <a:off x="311700" y="1152475"/>
+            <a:ext cx="8520600" cy="3416400"/>
+          </a:xfrm>
+          <a:prstGeom prst="rect">
+            <a:avLst/>
+          </a:prstGeom>
+        </p:spPr>
+        <p:txBody>
+          <a:bodyPr spcFirstLastPara="1" wrap="square" lIns="91425" tIns="91425" rIns="91425" bIns="91425" anchor="ctr" anchorCtr="0">
+            <a:noAutofit/>
+          </a:bodyPr>
+          <a:lstStyle/>
+          <a:p>
+            <a:pPr marL="0" lvl="0" indent="0" algn="l" rtl="0">
+              <a:spcBef>
+                <a:spcPts val="0"/>
+              </a:spcBef>
+              <a:spcAft>
+                <a:spcPts val="0"/>
+              </a:spcAft>
+              <a:buNone/>
+            </a:pPr>
+            <a:r>
+              <a:rPr lang="en">
+                <a:solidFill>
+                  <a:srgbClr val="FFFFFF"/>
+                </a:solidFill>
+                <a:latin typeface="Consolas"/>
+                <a:ea typeface="Consolas"/>
+                <a:cs typeface="Consolas"/>
+                <a:sym typeface="Consolas"/>
+              </a:rPr>
+              <a:t>GET / HTTP/2</a:t>
+            </a:r>
+            <a:endParaRPr>
+              <a:solidFill>
+                <a:srgbClr val="FFFFFF"/>
+              </a:solidFill>
+              <a:latin typeface="Consolas"/>
+              <a:ea typeface="Consolas"/>
+              <a:cs typeface="Consolas"/>
+              <a:sym typeface="Consolas"/>
+            </a:endParaRPr>
+          </a:p>
+          <a:p>
+            <a:pPr marL="0" lvl="0" indent="0" algn="l" rtl="0">
+              <a:spcBef>
+                <a:spcPts val="0"/>
+              </a:spcBef>
+              <a:spcAft>
+                <a:spcPts val="0"/>
+              </a:spcAft>
+              <a:buNone/>
+            </a:pPr>
+            <a:r>
+              <a:rPr lang="en">
+                <a:solidFill>
+                  <a:srgbClr val="FFFFFF"/>
+                </a:solidFill>
+                <a:latin typeface="Consolas"/>
+                <a:ea typeface="Consolas"/>
+                <a:cs typeface="Consolas"/>
+                <a:sym typeface="Consolas"/>
+              </a:rPr>
+              <a:t>Host: accounts.google.com</a:t>
+            </a:r>
+            <a:endParaRPr>
+              <a:solidFill>
+                <a:srgbClr val="FFFFFF"/>
+              </a:solidFill>
+              <a:latin typeface="Consolas"/>
+              <a:ea typeface="Consolas"/>
+              <a:cs typeface="Consolas"/>
+              <a:sym typeface="Consolas"/>
+            </a:endParaRPr>
+          </a:p>
+          <a:p>
+            <a:pPr marL="0" lvl="0" indent="0" algn="l" rtl="0">
+              <a:spcBef>
+                <a:spcPts val="0"/>
+              </a:spcBef>
+              <a:spcAft>
+                <a:spcPts val="0"/>
+              </a:spcAft>
+              <a:buNone/>
+            </a:pPr>
+            <a:endParaRPr>
+              <a:solidFill>
+                <a:srgbClr val="FFFFFF"/>
+              </a:solidFill>
+              <a:latin typeface="Consolas"/>
+              <a:ea typeface="Consolas"/>
+              <a:cs typeface="Consolas"/>
+              <a:sym typeface="Consolas"/>
+            </a:endParaRPr>
+          </a:p>
+          <a:p>
+            <a:pPr marL="0" lvl="0" indent="0" algn="l" rtl="0">
+              <a:spcBef>
+                <a:spcPts val="0"/>
+              </a:spcBef>
+              <a:spcAft>
+                <a:spcPts val="0"/>
+              </a:spcAft>
+              <a:buNone/>
+            </a:pPr>
+            <a:r>
+              <a:rPr lang="en">
+                <a:solidFill>
+                  <a:srgbClr val="FFFFFF"/>
+                </a:solidFill>
+                <a:latin typeface="Consolas"/>
+                <a:ea typeface="Consolas"/>
+                <a:cs typeface="Consolas"/>
+                <a:sym typeface="Consolas"/>
+              </a:rPr>
+              <a:t>...</a:t>
+            </a:r>
+            <a:endParaRPr>
+              <a:solidFill>
+                <a:srgbClr val="FFFFFF"/>
+              </a:solidFill>
+              <a:latin typeface="Consolas"/>
+              <a:ea typeface="Consolas"/>
+              <a:cs typeface="Consolas"/>
+              <a:sym typeface="Consolas"/>
+            </a:endParaRPr>
+          </a:p>
+        </p:txBody>
+      </p:sp>
+    </p:spTree>
+  </p:cSld>
+  <p:clrMapOvr>
+    <a:masterClrMapping/>
+  </p:clrMapOvr>
+</p:sld>
+</file>
+
+<file path=ppt/slides/slide31.xml><?xml version="1.0" encoding="utf-8"?>
+<p:sld xmlns:a="http://schemas.openxmlformats.org/drawingml/2006/main" xmlns:r="http://schemas.openxmlformats.org/officeDocument/2006/relationships" xmlns:p="http://schemas.openxmlformats.org/presentationml/2006/main">
+  <p:cSld>
+    <p:spTree>
+      <p:nvGrpSpPr>
         <p:cNvPr id="1" name="Shape 211"/>
         <p:cNvGrpSpPr/>
         <p:nvPr/>
@@ -13112,7 +14093,7 @@
 </p:sld>
 </file>
 
-<file path=ppt/slides/slide31.xml><?xml version="1.0" encoding="utf-8"?>
+<file path=ppt/slides/slide32.xml><?xml version="1.0" encoding="utf-8"?>
 <p:sld xmlns:a="http://schemas.openxmlformats.org/drawingml/2006/main" xmlns:r="http://schemas.openxmlformats.org/officeDocument/2006/relationships" xmlns:p="http://schemas.openxmlformats.org/presentationml/2006/main">
   <p:cSld>
     <p:spTree>
@@ -13195,7 +14176,7 @@
 </p:sld>
 </file>
 
-<file path=ppt/slides/slide32.xml><?xml version="1.0" encoding="utf-8"?>
+<file path=ppt/slides/slide33.xml><?xml version="1.0" encoding="utf-8"?>
 <p:sld xmlns:a="http://schemas.openxmlformats.org/drawingml/2006/main" xmlns:r="http://schemas.openxmlformats.org/officeDocument/2006/relationships" xmlns:p="http://schemas.openxmlformats.org/presentationml/2006/main">
   <p:cSld>
     <p:spTree>
@@ -13278,7 +14259,7 @@
 </p:sld>
 </file>
 
-<file path=ppt/slides/slide33.xml><?xml version="1.0" encoding="utf-8"?>
+<file path=ppt/slides/slide34.xml><?xml version="1.0" encoding="utf-8"?>
 <p:sld xmlns:a="http://schemas.openxmlformats.org/drawingml/2006/main" xmlns:r="http://schemas.openxmlformats.org/officeDocument/2006/relationships" xmlns:p="http://schemas.openxmlformats.org/presentationml/2006/main">
   <p:cSld>
     <p:spTree>
@@ -13345,7 +14326,7 @@
 </p:sld>
 </file>
 
-<file path=ppt/slides/slide34.xml><?xml version="1.0" encoding="utf-8"?>
+<file path=ppt/slides/slide35.xml><?xml version="1.0" encoding="utf-8"?>
 <p:sld xmlns:a="http://schemas.openxmlformats.org/drawingml/2006/main" xmlns:r="http://schemas.openxmlformats.org/officeDocument/2006/relationships" xmlns:p="http://schemas.openxmlformats.org/presentationml/2006/main">
   <p:cSld>
     <p:spTree>
@@ -13412,7 +14393,7 @@
 </p:sld>
 </file>
 
-<file path=ppt/slides/slide35.xml><?xml version="1.0" encoding="utf-8"?>
+<file path=ppt/slides/slide36.xml><?xml version="1.0" encoding="utf-8"?>
 <p:sld xmlns:a="http://schemas.openxmlformats.org/drawingml/2006/main" xmlns:r="http://schemas.openxmlformats.org/officeDocument/2006/relationships" xmlns:p="http://schemas.openxmlformats.org/presentationml/2006/main">
   <p:cSld>
     <p:spTree>
@@ -13791,7 +14772,7 @@
 </p:sld>
 </file>
 
-<file path=ppt/slides/slide36.xml><?xml version="1.0" encoding="utf-8"?>
+<file path=ppt/slides/slide37.xml><?xml version="1.0" encoding="utf-8"?>
 <p:sld xmlns:a="http://schemas.openxmlformats.org/drawingml/2006/main" xmlns:r="http://schemas.openxmlformats.org/officeDocument/2006/relationships" xmlns:p="http://schemas.openxmlformats.org/presentationml/2006/main">
   <p:cSld>
     <p:spTree>

</xml_diff>